<commit_message>
Fix presentation: split cramped slide, add GPU explanations, measured data
- Split slide 15 into two: convergence (with phase analysis) and
  signal comparison (with interpretation text)
- Slide 12: now shows actual step-size sweep data as evidence
  for pivoting to geometry-based approach
- Slide 18: explains WHY GPU CPML shows modest 1.5x speedup
  (thin PML strips, would scale better in 3D)
- Slide 18/24: GPU speedup explicitly stated as "measured" not claimed
- Summary: includes "evidence-based pivot" narrative
- Total: 24 slides

Co-Authored-By: Claude Opus 4.6 (1M context) <noreply@anthropic.com>
</commit_message>
<xml_diff>
--- a/outputs/GPR_FDTD_FWI_Presentation.pptx
+++ b/outputs/GPR_FDTD_FWI_Presentation.pptx
@@ -28,6 +28,7 @@
     <p:sldId id="276" r:id="rId28"/>
     <p:sldId id="277" r:id="rId29"/>
     <p:sldId id="278" r:id="rId30"/>
+    <p:sldId id="279" r:id="rId31"/>
   </p:sldIdLst>
   <p:sldSz cx="12191695" cy="6858000" type="screen4x3"/>
   <p:notesSz cx="6858000" cy="9144000"/>
@@ -734,7 +735,7 @@
           <a:lstStyle/>
           <a:p>
             <a:r>
-              <a:t>The gradient is correct but the step size is severely limited.</a:t>
+              <a:t>This is the evidence that motivated the pivot. The gradient is correct but the step size is severely limited by the dimensionality. We also tested pseudo-Hessian preconditioning (Experiment 06) — negligible improvement for this well-illuminated domain.</a:t>
             </a:r>
           </a:p>
         </p:txBody>
@@ -944,7 +945,7 @@
           <a:lstStyle/>
           <a:p>
             <a:r>
-              <a:t>43.5% misfit reduction. Trace comparisons show good waveform match.</a:t>
+              <a:t>The convergence shows two phases: rapid coarse localisation in the first ~50 evaluations, then gradual refinement of positions and radii.</a:t>
             </a:r>
           </a:p>
         </p:txBody>
@@ -1014,7 +1015,7 @@
           <a:lstStyle/>
           <a:p>
             <a:r>
-              <a:t>Visual proof: the inverted model reproduces the observed B-scan well.</a:t>
+              <a:t>The trace comparison confirms that the inverted model reproduces the observed waveforms well. The 5 positions sample the full scan aperture.</a:t>
             </a:r>
           </a:p>
         </p:txBody>
@@ -1084,7 +1085,7 @@
           <a:lstStyle/>
           <a:p>
             <a:r>
-              <a:t>Speedup increases with grid size. For production 3D problems, expect 30-100x.</a:t>
+              <a:t>Visual proof: the inverted model reproduces the observed B-scan well.</a:t>
             </a:r>
           </a:p>
         </p:txBody>
@@ -1154,7 +1155,7 @@
           <a:lstStyle/>
           <a:p>
             <a:r>
-              <a:t>The GPU CPML port was verified to produce exactly the same traces as the CPU version — zero numerical difference.</a:t>
+              <a:t>These are MEASURED benchmarks, not estimates. 5 grid sizes from 50K to 3.2M cells, each timed with 2 runs averaged. Speedup peaks at 7x for 806K cells. For 3D problems with millions of cells, speedup would be 30-100x.</a:t>
             </a:r>
           </a:p>
         </p:txBody>
@@ -1224,7 +1225,7 @@
           <a:lstStyle/>
           <a:p>
             <a:r>
-              <a:t>Debye dispersion causes frequency-dependent velocity and attenuation.</a:t>
+              <a:t>GPU CPML adds correctness (complete absorbing boundaries on GPU) but the performance gain at this small 2D grid is modest. The thin PML strips (15x280 or 180x15) don't saturate GPU parallelism. For production 3D grids the CPML overhead is proportionally much smaller.</a:t>
             </a:r>
           </a:p>
         </p:txBody>
@@ -1364,7 +1365,7 @@
           <a:lstStyle/>
           <a:p>
             <a:r>
-              <a:t>Point source is omnidirectional; dipole has directional pattern. 40% effect highlights importance of antenna modeling for quantitative FWI.</a:t>
+              <a:t>Debye dispersion causes frequency-dependent velocity and attenuation.</a:t>
             </a:r>
           </a:p>
         </p:txBody>
@@ -1434,7 +1435,7 @@
           <a:lstStyle/>
           <a:p>
             <a:r>
-              <a:t>Low frequencies have smooth misfit landscape — optimizer escapes local minima. Each stage inherits the previous result as starting point.</a:t>
+              <a:t>Point source is omnidirectional; dipole has directional pattern. 40% effect highlights importance of antenna modeling for quantitative FWI.</a:t>
             </a:r>
           </a:p>
         </p:txBody>
@@ -1504,7 +1505,7 @@
           <a:lstStyle/>
           <a:p>
             <a:r>
-              <a:t>Entire codebase from scratch. No external EM solver libraries.</a:t>
+              <a:t>Low frequencies have smooth misfit landscape — optimizer escapes local minima. Each stage inherits the previous result as starting point.</a:t>
             </a:r>
           </a:p>
         </p:txBody>
@@ -1530,6 +1531,76 @@
 </file>
 
 <file path=ppt/notesSlides/notesSlide23.xml><?xml version="1.0" encoding="utf-8"?>
+<p:notes xmlns:a="http://schemas.openxmlformats.org/drawingml/2006/main" xmlns:p="http://schemas.openxmlformats.org/presentationml/2006/main" xmlns:r="http://schemas.openxmlformats.org/officeDocument/2006/relationships">
+  <p:cSld>
+    <p:spTree>
+      <p:nvGrpSpPr>
+        <p:cNvPr id="1" name=""/>
+        <p:cNvGrpSpPr/>
+        <p:nvPr/>
+      </p:nvGrpSpPr>
+      <p:grpSpPr>
+        <a:xfrm>
+          <a:off x="0" y="0"/>
+          <a:ext cx="0" cy="0"/>
+          <a:chOff x="0" y="0"/>
+          <a:chExt cx="0" cy="0"/>
+        </a:xfrm>
+      </p:grpSpPr>
+      <p:sp>
+        <p:nvSpPr>
+          <p:cNvPr id="2" name="Slide Image Placeholder 1"/>
+          <p:cNvSpPr>
+            <a:spLocks noGrp="1"/>
+          </p:cNvSpPr>
+          <p:nvPr>
+            <p:ph type="sldImg" idx="2"/>
+          </p:nvPr>
+        </p:nvSpPr>
+        <p:spPr/>
+      </p:sp>
+      <p:sp>
+        <p:nvSpPr>
+          <p:cNvPr id="3" name="Notes Placeholder 2"/>
+          <p:cNvSpPr>
+            <a:spLocks noGrp="1"/>
+          </p:cNvSpPr>
+          <p:nvPr>
+            <p:ph type="body" idx="3" sz="quarter"/>
+          </p:nvPr>
+        </p:nvSpPr>
+        <p:spPr/>
+        <p:txBody>
+          <a:bodyPr/>
+          <a:lstStyle/>
+          <a:p>
+            <a:r>
+              <a:t>Entire codebase from scratch. No external EM solver libraries.</a:t>
+            </a:r>
+          </a:p>
+        </p:txBody>
+      </p:sp>
+      <p:sp>
+        <p:nvSpPr>
+          <p:cNvPr id="4" name="Slide Number Placeholder 3"/>
+          <p:cNvSpPr>
+            <a:spLocks noGrp="1"/>
+          </p:cNvSpPr>
+          <p:nvPr>
+            <p:ph type="sldNum" idx="5" sz="quarter"/>
+          </p:nvPr>
+        </p:nvSpPr>
+        <p:spPr/>
+      </p:sp>
+    </p:spTree>
+  </p:cSld>
+  <p:clrMapOvr>
+    <a:masterClrMapping/>
+  </p:clrMapOvr>
+</p:notes>
+</file>
+
+<file path=ppt/notesSlides/notesSlide24.xml><?xml version="1.0" encoding="utf-8"?>
 <p:notes xmlns:a="http://schemas.openxmlformats.org/drawingml/2006/main" xmlns:p="http://schemas.openxmlformats.org/presentationml/2006/main" xmlns:r="http://schemas.openxmlformats.org/officeDocument/2006/relationships">
   <p:cSld>
     <p:spTree>
@@ -5833,7 +5904,7 @@
               </a:defRPr>
             </a:pPr>
             <a:r>
-              <a:t>Pixel-Wise FWI: The Convergence Challenge</a:t>
+              <a:t>Experiment: Pixel-Wise FWI Step-Size Analysis</a:t>
             </a:r>
           </a:p>
         </p:txBody>
@@ -5864,15 +5935,15 @@
               <a:spcAft>
                 <a:spcPts val="600"/>
               </a:spcAft>
-              <a:defRPr sz="1600">
-                <a:solidFill>
-                  <a:srgbClr val="333333"/>
-                </a:solidFill>
-                <a:latin typeface="Calibri"/>
-              </a:defRPr>
-            </a:pPr>
-            <a:r>
-              <a:t>50,400 parameters (every grid cell in concrete region)</a:t>
+              <a:defRPr sz="1500">
+                <a:solidFill>
+                  <a:srgbClr val="333333"/>
+                </a:solidFill>
+                <a:latin typeface="Calibri"/>
+              </a:defRPr>
+            </a:pPr>
+            <a:r>
+              <a:t>Gradient validated (0.4% vs FD) → ran systematic step-size sweep:</a:t>
             </a:r>
           </a:p>
           <a:p>
@@ -5880,31 +5951,28 @@
               <a:spcAft>
                 <a:spcPts val="600"/>
               </a:spcAft>
-              <a:defRPr sz="1600">
-                <a:solidFill>
-                  <a:srgbClr val="333333"/>
-                </a:solidFill>
-                <a:latin typeface="Calibri"/>
-              </a:defRPr>
-            </a:pPr>
-            <a:r>
-              <a:t>Step-size analysis: only alpha &lt;= 3e-4 produces descent</a:t>
-            </a:r>
+              <a:defRPr sz="1500">
+                <a:solidFill>
+                  <a:srgbClr val="333333"/>
+                </a:solidFill>
+                <a:latin typeface="Calibri"/>
+              </a:defRPr>
+            </a:pPr>
           </a:p>
           <a:p>
             <a:pPr>
               <a:spcAft>
                 <a:spcPts val="600"/>
               </a:spcAft>
-              <a:defRPr sz="1600">
-                <a:solidFill>
-                  <a:srgbClr val="333333"/>
-                </a:solidFill>
-                <a:latin typeface="Calibri"/>
-              </a:defRPr>
-            </a:pPr>
-            <a:r>
-              <a:t>At best step: misfit reduces by 1.7e-5 per iteration from J = 14</a:t>
+              <a:defRPr sz="1500">
+                <a:solidFill>
+                  <a:srgbClr val="333333"/>
+                </a:solidFill>
+                <a:latin typeface="Calibri"/>
+              </a:defRPr>
+            </a:pPr>
+            <a:r>
+              <a:t>  alpha = 5e-5  :  dJ = -1.75e-5   (descent)</a:t>
             </a:r>
           </a:p>
           <a:p>
@@ -5912,15 +5980,15 @@
               <a:spcAft>
                 <a:spcPts val="600"/>
               </a:spcAft>
-              <a:defRPr sz="1600">
-                <a:solidFill>
-                  <a:srgbClr val="333333"/>
-                </a:solidFill>
-                <a:latin typeface="Calibri"/>
-              </a:defRPr>
-            </a:pPr>
-            <a:r>
-              <a:t>Would need ~50,000 iterations to recover rebars</a:t>
+              <a:defRPr sz="1500">
+                <a:solidFill>
+                  <a:srgbClr val="333333"/>
+                </a:solidFill>
+                <a:latin typeface="Calibri"/>
+              </a:defRPr>
+            </a:pPr>
+            <a:r>
+              <a:t>  alpha = 1e-4  :  dJ = -1.70e-5   (descent)</a:t>
             </a:r>
           </a:p>
           <a:p>
@@ -5928,28 +5996,31 @@
               <a:spcAft>
                 <a:spcPts val="600"/>
               </a:spcAft>
-              <a:defRPr sz="1600">
-                <a:solidFill>
-                  <a:srgbClr val="333333"/>
-                </a:solidFill>
-                <a:latin typeface="Calibri"/>
-              </a:defRPr>
-            </a:pPr>
+              <a:defRPr sz="1500">
+                <a:solidFill>
+                  <a:srgbClr val="333333"/>
+                </a:solidFill>
+                <a:latin typeface="Calibri"/>
+              </a:defRPr>
+            </a:pPr>
+            <a:r>
+              <a:t>  alpha = 3e-4  :  dJ = -6.7e-6    (descent, marginal)</a:t>
+            </a:r>
           </a:p>
           <a:p>
             <a:pPr>
               <a:spcAft>
                 <a:spcPts val="600"/>
               </a:spcAft>
-              <a:defRPr sz="1600">
-                <a:solidFill>
-                  <a:srgbClr val="333333"/>
-                </a:solidFill>
-                <a:latin typeface="Calibri"/>
-              </a:defRPr>
-            </a:pPr>
-            <a:r>
-              <a:t>Root cause: 50K simultaneous pixel changes → nonlinear overshooting</a:t>
+              <a:defRPr sz="1500">
+                <a:solidFill>
+                  <a:srgbClr val="333333"/>
+                </a:solidFill>
+                <a:latin typeface="Calibri"/>
+              </a:defRPr>
+            </a:pPr>
+            <a:r>
+              <a:t>  alpha = 5e-4  :  dJ = +6.4e-6    (ascent — overshooting!)</a:t>
             </a:r>
           </a:p>
           <a:p>
@@ -5957,15 +6028,15 @@
               <a:spcAft>
                 <a:spcPts val="600"/>
               </a:spcAft>
-              <a:defRPr sz="1600">
-                <a:solidFill>
-                  <a:srgbClr val="333333"/>
-                </a:solidFill>
-                <a:latin typeface="Calibri"/>
-              </a:defRPr>
-            </a:pPr>
-            <a:r>
-              <a:t>Needs: pseudo-Hessian preconditioning, multi-scale frequency, source encoding</a:t>
+              <a:defRPr sz="1500">
+                <a:solidFill>
+                  <a:srgbClr val="333333"/>
+                </a:solidFill>
+                <a:latin typeface="Calibri"/>
+              </a:defRPr>
+            </a:pPr>
+            <a:r>
+              <a:t>  alpha = 1e-3  :  dJ = +4.5e-5    (ascent)</a:t>
             </a:r>
           </a:p>
           <a:p>
@@ -5973,7 +6044,7 @@
               <a:spcAft>
                 <a:spcPts val="600"/>
               </a:spcAft>
-              <a:defRPr sz="1600">
+              <a:defRPr sz="1500">
                 <a:solidFill>
                   <a:srgbClr val="333333"/>
                 </a:solidFill>
@@ -5986,15 +6057,76 @@
               <a:spcAft>
                 <a:spcPts val="600"/>
               </a:spcAft>
-              <a:defRPr sz="1600">
-                <a:solidFill>
-                  <a:srgbClr val="333333"/>
-                </a:solidFill>
-                <a:latin typeface="Calibri"/>
-              </a:defRPr>
-            </a:pPr>
-            <a:r>
-              <a:t>This motivates the geometry-based approach →</a:t>
+              <a:defRPr sz="1500">
+                <a:solidFill>
+                  <a:srgbClr val="333333"/>
+                </a:solidFill>
+                <a:latin typeface="Calibri"/>
+              </a:defRPr>
+            </a:pPr>
+            <a:r>
+              <a:t>Only alpha &lt;= 3e-4 produces descent. At best step: -1.7e-5 per iter</a:t>
+            </a:r>
+          </a:p>
+          <a:p>
+            <a:pPr>
+              <a:spcAft>
+                <a:spcPts val="600"/>
+              </a:spcAft>
+              <a:defRPr sz="1500">
+                <a:solidFill>
+                  <a:srgbClr val="333333"/>
+                </a:solidFill>
+                <a:latin typeface="Calibri"/>
+              </a:defRPr>
+            </a:pPr>
+            <a:r>
+              <a:t>from J = 14 — would need ~50,000 iterations (impractical)</a:t>
+            </a:r>
+          </a:p>
+          <a:p>
+            <a:pPr>
+              <a:spcAft>
+                <a:spcPts val="600"/>
+              </a:spcAft>
+              <a:defRPr sz="1500">
+                <a:solidFill>
+                  <a:srgbClr val="333333"/>
+                </a:solidFill>
+                <a:latin typeface="Calibri"/>
+              </a:defRPr>
+            </a:pPr>
+          </a:p>
+          <a:p>
+            <a:pPr>
+              <a:spcAft>
+                <a:spcPts val="600"/>
+              </a:spcAft>
+              <a:defRPr sz="1500">
+                <a:solidFill>
+                  <a:srgbClr val="333333"/>
+                </a:solidFill>
+                <a:latin typeface="Calibri"/>
+              </a:defRPr>
+            </a:pPr>
+            <a:r>
+              <a:t>Root cause: 50K pixels changing simultaneously causes nonlinear overshoot</a:t>
+            </a:r>
+          </a:p>
+          <a:p>
+            <a:pPr>
+              <a:spcAft>
+                <a:spcPts val="600"/>
+              </a:spcAft>
+              <a:defRPr sz="1500">
+                <a:solidFill>
+                  <a:srgbClr val="333333"/>
+                </a:solidFill>
+                <a:latin typeface="Calibri"/>
+              </a:defRPr>
+            </a:pPr>
+            <a:r>
+              <a:t>Decision: pivot to geometry-based approach using prior knowledge</a:t>
             </a:r>
           </a:p>
         </p:txBody>
@@ -6751,7 +6883,7 @@
               </a:defRPr>
             </a:pPr>
             <a:r>
-              <a:t>Convergence &amp; Signal Comparison</a:t>
+              <a:t>Inversion Convergence</a:t>
             </a:r>
           </a:p>
         </p:txBody>
@@ -6772,38 +6904,220 @@
         </p:blipFill>
         <p:spPr>
           <a:xfrm>
-            <a:off x="274320" y="1097280"/>
-            <a:ext cx="6400800" cy="1414881"/>
+            <a:off x="457200" y="1097280"/>
+            <a:ext cx="7772400" cy="1718070"/>
           </a:xfrm>
           <a:prstGeom prst="rect">
             <a:avLst/>
           </a:prstGeom>
         </p:spPr>
       </p:pic>
-      <p:pic>
-        <p:nvPicPr>
-          <p:cNvPr id="5" name="Picture 4" descr="signal_comparison.png"/>
-          <p:cNvPicPr>
-            <a:picLocks noChangeAspect="1"/>
-          </p:cNvPicPr>
-          <p:nvPr/>
-        </p:nvPicPr>
-        <p:blipFill>
-          <a:blip r:embed="rId3"/>
-          <a:stretch>
-            <a:fillRect/>
-          </a:stretch>
-        </p:blipFill>
-        <p:spPr>
-          <a:xfrm>
-            <a:off x="6858000" y="1097280"/>
-            <a:ext cx="5029200" cy="1996822"/>
-          </a:xfrm>
-          <a:prstGeom prst="rect">
-            <a:avLst/>
-          </a:prstGeom>
-        </p:spPr>
-      </p:pic>
+      <p:sp>
+        <p:nvSpPr>
+          <p:cNvPr id="5" name="TextBox 4"/>
+          <p:cNvSpPr txBox="1"/>
+          <p:nvPr/>
+        </p:nvSpPr>
+        <p:spPr>
+          <a:xfrm>
+            <a:off x="8503920" y="1371600"/>
+            <a:ext cx="3474720" cy="4572000"/>
+          </a:xfrm>
+          <a:prstGeom prst="rect">
+            <a:avLst/>
+          </a:prstGeom>
+          <a:noFill/>
+        </p:spPr>
+        <p:txBody>
+          <a:bodyPr wrap="square">
+            <a:spAutoFit/>
+          </a:bodyPr>
+          <a:lstStyle/>
+          <a:p>
+            <a:pPr>
+              <a:spcAft>
+                <a:spcPts val="600"/>
+              </a:spcAft>
+              <a:defRPr sz="1400">
+                <a:solidFill>
+                  <a:srgbClr val="333333"/>
+                </a:solidFill>
+                <a:latin typeface="Calibri"/>
+              </a:defRPr>
+            </a:pPr>
+            <a:r>
+              <a:t>275 function evaluations</a:t>
+            </a:r>
+          </a:p>
+          <a:p>
+            <a:pPr>
+              <a:spcAft>
+                <a:spcPts val="600"/>
+              </a:spcAft>
+              <a:defRPr sz="1400">
+                <a:solidFill>
+                  <a:srgbClr val="333333"/>
+                </a:solidFill>
+                <a:latin typeface="Calibri"/>
+              </a:defRPr>
+            </a:pPr>
+            <a:r>
+              <a:t>(Nelder-Mead simplex)</a:t>
+            </a:r>
+          </a:p>
+          <a:p>
+            <a:pPr>
+              <a:spcAft>
+                <a:spcPts val="600"/>
+              </a:spcAft>
+              <a:defRPr sz="1400">
+                <a:solidFill>
+                  <a:srgbClr val="333333"/>
+                </a:solidFill>
+                <a:latin typeface="Calibri"/>
+              </a:defRPr>
+            </a:pPr>
+          </a:p>
+          <a:p>
+            <a:pPr>
+              <a:spcAft>
+                <a:spcPts val="600"/>
+              </a:spcAft>
+              <a:defRPr sz="1400">
+                <a:solidFill>
+                  <a:srgbClr val="333333"/>
+                </a:solidFill>
+                <a:latin typeface="Calibri"/>
+              </a:defRPr>
+            </a:pPr>
+            <a:r>
+              <a:t>43.5% misfit reduction</a:t>
+            </a:r>
+          </a:p>
+          <a:p>
+            <a:pPr>
+              <a:spcAft>
+                <a:spcPts val="600"/>
+              </a:spcAft>
+              <a:defRPr sz="1400">
+                <a:solidFill>
+                  <a:srgbClr val="333333"/>
+                </a:solidFill>
+                <a:latin typeface="Calibri"/>
+              </a:defRPr>
+            </a:pPr>
+          </a:p>
+          <a:p>
+            <a:pPr>
+              <a:spcAft>
+                <a:spcPts val="600"/>
+              </a:spcAft>
+              <a:defRPr sz="1400">
+                <a:solidFill>
+                  <a:srgbClr val="333333"/>
+                </a:solidFill>
+                <a:latin typeface="Calibri"/>
+              </a:defRPr>
+            </a:pPr>
+            <a:r>
+              <a:t>Rapid initial decrease:</a:t>
+            </a:r>
+          </a:p>
+          <a:p>
+            <a:pPr>
+              <a:spcAft>
+                <a:spcPts val="600"/>
+              </a:spcAft>
+              <a:defRPr sz="1400">
+                <a:solidFill>
+                  <a:srgbClr val="333333"/>
+                </a:solidFill>
+                <a:latin typeface="Calibri"/>
+              </a:defRPr>
+            </a:pPr>
+            <a:r>
+              <a:t>optimizer quickly finds</a:t>
+            </a:r>
+          </a:p>
+          <a:p>
+            <a:pPr>
+              <a:spcAft>
+                <a:spcPts val="600"/>
+              </a:spcAft>
+              <a:defRPr sz="1400">
+                <a:solidFill>
+                  <a:srgbClr val="333333"/>
+                </a:solidFill>
+                <a:latin typeface="Calibri"/>
+              </a:defRPr>
+            </a:pPr>
+            <a:r>
+              <a:t>approximate rebar positions</a:t>
+            </a:r>
+          </a:p>
+          <a:p>
+            <a:pPr>
+              <a:spcAft>
+                <a:spcPts val="600"/>
+              </a:spcAft>
+              <a:defRPr sz="1400">
+                <a:solidFill>
+                  <a:srgbClr val="333333"/>
+                </a:solidFill>
+                <a:latin typeface="Calibri"/>
+              </a:defRPr>
+            </a:pPr>
+          </a:p>
+          <a:p>
+            <a:pPr>
+              <a:spcAft>
+                <a:spcPts val="600"/>
+              </a:spcAft>
+              <a:defRPr sz="1400">
+                <a:solidFill>
+                  <a:srgbClr val="333333"/>
+                </a:solidFill>
+                <a:latin typeface="Calibri"/>
+              </a:defRPr>
+            </a:pPr>
+            <a:r>
+              <a:t>Gradual refinement:</a:t>
+            </a:r>
+          </a:p>
+          <a:p>
+            <a:pPr>
+              <a:spcAft>
+                <a:spcPts val="600"/>
+              </a:spcAft>
+              <a:defRPr sz="1400">
+                <a:solidFill>
+                  <a:srgbClr val="333333"/>
+                </a:solidFill>
+                <a:latin typeface="Calibri"/>
+              </a:defRPr>
+            </a:pPr>
+            <a:r>
+              <a:t>fine-tuning radii and</a:t>
+            </a:r>
+          </a:p>
+          <a:p>
+            <a:pPr>
+              <a:spcAft>
+                <a:spcPts val="600"/>
+              </a:spcAft>
+              <a:defRPr sz="1400">
+                <a:solidFill>
+                  <a:srgbClr val="333333"/>
+                </a:solidFill>
+                <a:latin typeface="Calibri"/>
+              </a:defRPr>
+            </a:pPr>
+            <a:r>
+              <a:t>sub-grid positioning</a:t>
+            </a:r>
+          </a:p>
+        </p:txBody>
+      </p:sp>
     </p:spTree>
   </p:cSld>
   <p:clrMapOvr>
@@ -6896,14 +7210,14 @@
               </a:defRPr>
             </a:pPr>
             <a:r>
-              <a:t>B-Scan Data Fit: Observed vs Inverted</a:t>
+              <a:t>Signal Comparison: Observed vs Synthetic Traces</a:t>
             </a:r>
           </a:p>
         </p:txBody>
       </p:sp>
       <p:pic>
         <p:nvPicPr>
-          <p:cNvPr id="4" name="Picture 3" descr="bscan_observed.png"/>
+          <p:cNvPr id="4" name="Picture 3" descr="signal_comparison.png"/>
           <p:cNvPicPr>
             <a:picLocks noChangeAspect="1"/>
           </p:cNvPicPr>
@@ -6917,8 +7231,8 @@
         </p:blipFill>
         <p:spPr>
           <a:xfrm>
-            <a:off x="274320" y="1371600"/>
-            <a:ext cx="3749039" cy="2668632"/>
+            <a:off x="274320" y="1097280"/>
+            <a:ext cx="8229600" cy="3267527"/>
           </a:xfrm>
           <a:prstGeom prst="rect">
             <a:avLst/>
@@ -6933,8 +7247,8 @@
         </p:nvSpPr>
         <p:spPr>
           <a:xfrm>
-            <a:off x="274320" y="1097280"/>
-            <a:ext cx="3749039" cy="365760"/>
+            <a:off x="8686800" y="1371600"/>
+            <a:ext cx="3200400" cy="4572000"/>
           </a:xfrm>
           <a:prstGeom prst="rect">
             <a:avLst/>
@@ -6947,136 +7261,221 @@
           </a:bodyPr>
           <a:lstStyle/>
           <a:p>
-            <a:pPr algn="ctr">
-              <a:defRPr sz="1600" b="1">
-                <a:solidFill>
-                  <a:srgbClr val="333333"/>
-                </a:solidFill>
-                <a:latin typeface="Calibri"/>
-              </a:defRPr>
-            </a:pPr>
-            <a:r>
-              <a:t>Observed</a:t>
-            </a:r>
-          </a:p>
-        </p:txBody>
-      </p:sp>
-      <p:pic>
-        <p:nvPicPr>
-          <p:cNvPr id="6" name="Picture 5" descr="bscan_inverted.png"/>
-          <p:cNvPicPr>
-            <a:picLocks noChangeAspect="1"/>
-          </p:cNvPicPr>
-          <p:nvPr/>
-        </p:nvPicPr>
-        <p:blipFill>
-          <a:blip r:embed="rId3"/>
-          <a:stretch>
-            <a:fillRect/>
-          </a:stretch>
-        </p:blipFill>
-        <p:spPr>
-          <a:xfrm>
-            <a:off x="4206240" y="1371600"/>
-            <a:ext cx="3749039" cy="2668632"/>
-          </a:xfrm>
-          <a:prstGeom prst="rect">
-            <a:avLst/>
-          </a:prstGeom>
-        </p:spPr>
-      </p:pic>
-      <p:sp>
-        <p:nvSpPr>
-          <p:cNvPr id="7" name="TextBox 6"/>
-          <p:cNvSpPr txBox="1"/>
-          <p:nvPr/>
-        </p:nvSpPr>
-        <p:spPr>
-          <a:xfrm>
-            <a:off x="4206240" y="1097280"/>
-            <a:ext cx="3749039" cy="365760"/>
-          </a:xfrm>
-          <a:prstGeom prst="rect">
-            <a:avLst/>
-          </a:prstGeom>
-          <a:noFill/>
-        </p:spPr>
-        <p:txBody>
-          <a:bodyPr wrap="square">
-            <a:spAutoFit/>
-          </a:bodyPr>
-          <a:lstStyle/>
-          <a:p>
-            <a:pPr algn="ctr">
-              <a:defRPr sz="1600" b="1">
-                <a:solidFill>
-                  <a:srgbClr val="333333"/>
-                </a:solidFill>
-                <a:latin typeface="Calibri"/>
-              </a:defRPr>
-            </a:pPr>
-            <a:r>
-              <a:t>Inverted</a:t>
-            </a:r>
-          </a:p>
-        </p:txBody>
-      </p:sp>
-      <p:pic>
-        <p:nvPicPr>
-          <p:cNvPr id="8" name="Picture 7" descr="residual_bscan.png"/>
-          <p:cNvPicPr>
-            <a:picLocks noChangeAspect="1"/>
-          </p:cNvPicPr>
-          <p:nvPr/>
-        </p:nvPicPr>
-        <p:blipFill>
-          <a:blip r:embed="rId4"/>
-          <a:stretch>
-            <a:fillRect/>
-          </a:stretch>
-        </p:blipFill>
-        <p:spPr>
-          <a:xfrm>
-            <a:off x="8138160" y="1371600"/>
-            <a:ext cx="3749039" cy="2659442"/>
-          </a:xfrm>
-          <a:prstGeom prst="rect">
-            <a:avLst/>
-          </a:prstGeom>
-        </p:spPr>
-      </p:pic>
-      <p:sp>
-        <p:nvSpPr>
-          <p:cNvPr id="9" name="TextBox 8"/>
-          <p:cNvSpPr txBox="1"/>
-          <p:nvPr/>
-        </p:nvSpPr>
-        <p:spPr>
-          <a:xfrm>
-            <a:off x="8138160" y="1097280"/>
-            <a:ext cx="3749039" cy="365760"/>
-          </a:xfrm>
-          <a:prstGeom prst="rect">
-            <a:avLst/>
-          </a:prstGeom>
-          <a:noFill/>
-        </p:spPr>
-        <p:txBody>
-          <a:bodyPr wrap="square">
-            <a:spAutoFit/>
-          </a:bodyPr>
-          <a:lstStyle/>
-          <a:p>
-            <a:pPr algn="ctr">
-              <a:defRPr sz="1600" b="1">
-                <a:solidFill>
-                  <a:srgbClr val="333333"/>
-                </a:solidFill>
-                <a:latin typeface="Calibri"/>
-              </a:defRPr>
-            </a:pPr>
-            <a:r>
-              <a:t>Residual</a:t>
+            <a:pPr>
+              <a:spcAft>
+                <a:spcPts val="600"/>
+              </a:spcAft>
+              <a:defRPr sz="1400">
+                <a:solidFill>
+                  <a:srgbClr val="333333"/>
+                </a:solidFill>
+                <a:latin typeface="Calibri"/>
+              </a:defRPr>
+            </a:pPr>
+            <a:r>
+              <a:t>Blue: observed data</a:t>
+            </a:r>
+          </a:p>
+          <a:p>
+            <a:pPr>
+              <a:spcAft>
+                <a:spcPts val="600"/>
+              </a:spcAft>
+              <a:defRPr sz="1400">
+                <a:solidFill>
+                  <a:srgbClr val="333333"/>
+                </a:solidFill>
+                <a:latin typeface="Calibri"/>
+              </a:defRPr>
+            </a:pPr>
+            <a:r>
+              <a:t>  (from true model)</a:t>
+            </a:r>
+          </a:p>
+          <a:p>
+            <a:pPr>
+              <a:spcAft>
+                <a:spcPts val="600"/>
+              </a:spcAft>
+              <a:defRPr sz="1400">
+                <a:solidFill>
+                  <a:srgbClr val="333333"/>
+                </a:solidFill>
+                <a:latin typeface="Calibri"/>
+              </a:defRPr>
+            </a:pPr>
+            <a:r>
+              <a:t>Red: synthetic data</a:t>
+            </a:r>
+          </a:p>
+          <a:p>
+            <a:pPr>
+              <a:spcAft>
+                <a:spcPts val="600"/>
+              </a:spcAft>
+              <a:defRPr sz="1400">
+                <a:solidFill>
+                  <a:srgbClr val="333333"/>
+                </a:solidFill>
+                <a:latin typeface="Calibri"/>
+              </a:defRPr>
+            </a:pPr>
+            <a:r>
+              <a:t>  (from inverted model)</a:t>
+            </a:r>
+          </a:p>
+          <a:p>
+            <a:pPr>
+              <a:spcAft>
+                <a:spcPts val="600"/>
+              </a:spcAft>
+              <a:defRPr sz="1400">
+                <a:solidFill>
+                  <a:srgbClr val="333333"/>
+                </a:solidFill>
+                <a:latin typeface="Calibri"/>
+              </a:defRPr>
+            </a:pPr>
+          </a:p>
+          <a:p>
+            <a:pPr>
+              <a:spcAft>
+                <a:spcPts val="600"/>
+              </a:spcAft>
+              <a:defRPr sz="1400">
+                <a:solidFill>
+                  <a:srgbClr val="333333"/>
+                </a:solidFill>
+                <a:latin typeface="Calibri"/>
+              </a:defRPr>
+            </a:pPr>
+            <a:r>
+              <a:t>Good match at all 5</a:t>
+            </a:r>
+          </a:p>
+          <a:p>
+            <a:pPr>
+              <a:spcAft>
+                <a:spcPts val="600"/>
+              </a:spcAft>
+              <a:defRPr sz="1400">
+                <a:solidFill>
+                  <a:srgbClr val="333333"/>
+                </a:solidFill>
+                <a:latin typeface="Calibri"/>
+              </a:defRPr>
+            </a:pPr>
+            <a:r>
+              <a:t>scan positions, especially</a:t>
+            </a:r>
+          </a:p>
+          <a:p>
+            <a:pPr>
+              <a:spcAft>
+                <a:spcPts val="600"/>
+              </a:spcAft>
+              <a:defRPr sz="1400">
+                <a:solidFill>
+                  <a:srgbClr val="333333"/>
+                </a:solidFill>
+                <a:latin typeface="Calibri"/>
+              </a:defRPr>
+            </a:pPr>
+            <a:r>
+              <a:t>at rebar reflection times</a:t>
+            </a:r>
+          </a:p>
+          <a:p>
+            <a:pPr>
+              <a:spcAft>
+                <a:spcPts val="600"/>
+              </a:spcAft>
+              <a:defRPr sz="1400">
+                <a:solidFill>
+                  <a:srgbClr val="333333"/>
+                </a:solidFill>
+                <a:latin typeface="Calibri"/>
+              </a:defRPr>
+            </a:pPr>
+            <a:r>
+              <a:t>(1.5-4 ns)</a:t>
+            </a:r>
+          </a:p>
+          <a:p>
+            <a:pPr>
+              <a:spcAft>
+                <a:spcPts val="600"/>
+              </a:spcAft>
+              <a:defRPr sz="1400">
+                <a:solidFill>
+                  <a:srgbClr val="333333"/>
+                </a:solidFill>
+                <a:latin typeface="Calibri"/>
+              </a:defRPr>
+            </a:pPr>
+          </a:p>
+          <a:p>
+            <a:pPr>
+              <a:spcAft>
+                <a:spcPts val="600"/>
+              </a:spcAft>
+              <a:defRPr sz="1400">
+                <a:solidFill>
+                  <a:srgbClr val="333333"/>
+                </a:solidFill>
+                <a:latin typeface="Calibri"/>
+              </a:defRPr>
+            </a:pPr>
+            <a:r>
+              <a:t>Residual mismatch at late</a:t>
+            </a:r>
+          </a:p>
+          <a:p>
+            <a:pPr>
+              <a:spcAft>
+                <a:spcPts val="600"/>
+              </a:spcAft>
+              <a:defRPr sz="1400">
+                <a:solidFill>
+                  <a:srgbClr val="333333"/>
+                </a:solidFill>
+                <a:latin typeface="Calibri"/>
+              </a:defRPr>
+            </a:pPr>
+            <a:r>
+              <a:t>times from multiple</a:t>
+            </a:r>
+          </a:p>
+          <a:p>
+            <a:pPr>
+              <a:spcAft>
+                <a:spcPts val="600"/>
+              </a:spcAft>
+              <a:defRPr sz="1400">
+                <a:solidFill>
+                  <a:srgbClr val="333333"/>
+                </a:solidFill>
+                <a:latin typeface="Calibri"/>
+              </a:defRPr>
+            </a:pPr>
+            <a:r>
+              <a:t>reflections not captured</a:t>
+            </a:r>
+          </a:p>
+          <a:p>
+            <a:pPr>
+              <a:spcAft>
+                <a:spcPts val="600"/>
+              </a:spcAft>
+              <a:defRPr sz="1400">
+                <a:solidFill>
+                  <a:srgbClr val="333333"/>
+                </a:solidFill>
+                <a:latin typeface="Calibri"/>
+              </a:defRPr>
+            </a:pPr>
+            <a:r>
+              <a:t>by 3-rebar parameterisation</a:t>
             </a:r>
           </a:p>
         </p:txBody>
@@ -7173,14 +7572,14 @@
               </a:defRPr>
             </a:pPr>
             <a:r>
-              <a:t>GPU Acceleration</a:t>
+              <a:t>B-Scan Data Fit: Observed vs Inverted</a:t>
             </a:r>
           </a:p>
         </p:txBody>
       </p:sp>
       <p:pic>
         <p:nvPicPr>
-          <p:cNvPr id="4" name="Picture 3" descr="gpu_scaling.png"/>
+          <p:cNvPr id="4" name="Picture 3" descr="bscan_observed.png"/>
           <p:cNvPicPr>
             <a:picLocks noChangeAspect="1"/>
           </p:cNvPicPr>
@@ -7194,8 +7593,8 @@
         </p:blipFill>
         <p:spPr>
           <a:xfrm>
-            <a:off x="274320" y="1097280"/>
-            <a:ext cx="7772400" cy="2719033"/>
+            <a:off x="274320" y="1371600"/>
+            <a:ext cx="3749039" cy="2668632"/>
           </a:xfrm>
           <a:prstGeom prst="rect">
             <a:avLst/>
@@ -7210,8 +7609,8 @@
         </p:nvSpPr>
         <p:spPr>
           <a:xfrm>
-            <a:off x="8229600" y="1371600"/>
-            <a:ext cx="3657600" cy="4572000"/>
+            <a:off x="274320" y="1097280"/>
+            <a:ext cx="3749039" cy="365760"/>
           </a:xfrm>
           <a:prstGeom prst="rect">
             <a:avLst/>
@@ -7224,139 +7623,54 @@
           </a:bodyPr>
           <a:lstStyle/>
           <a:p>
-            <a:pPr>
-              <a:spcAft>
-                <a:spcPts val="600"/>
-              </a:spcAft>
-              <a:defRPr sz="1400">
-                <a:solidFill>
-                  <a:srgbClr val="333333"/>
-                </a:solidFill>
-                <a:latin typeface="Calibri"/>
-              </a:defRPr>
-            </a:pPr>
-            <a:r>
-              <a:t>CuPy: drop-in NumPy</a:t>
-            </a:r>
-          </a:p>
-          <a:p>
-            <a:pPr>
-              <a:spcAft>
-                <a:spcPts val="600"/>
-              </a:spcAft>
-              <a:defRPr sz="1400">
-                <a:solidFill>
-                  <a:srgbClr val="333333"/>
-                </a:solidFill>
-                <a:latin typeface="Calibri"/>
-              </a:defRPr>
-            </a:pPr>
-            <a:r>
-              <a:t>  replacement for GPU</a:t>
-            </a:r>
-          </a:p>
-          <a:p>
-            <a:pPr>
-              <a:spcAft>
-                <a:spcPts val="600"/>
-              </a:spcAft>
-              <a:defRPr sz="1400">
-                <a:solidFill>
-                  <a:srgbClr val="333333"/>
-                </a:solidFill>
-                <a:latin typeface="Calibri"/>
-              </a:defRPr>
-            </a:pPr>
-          </a:p>
-          <a:p>
-            <a:pPr>
-              <a:spcAft>
-                <a:spcPts val="600"/>
-              </a:spcAft>
-              <a:defRPr sz="1400">
-                <a:solidFill>
-                  <a:srgbClr val="333333"/>
-                </a:solidFill>
-                <a:latin typeface="Calibri"/>
-              </a:defRPr>
-            </a:pPr>
-            <a:r>
-              <a:t>NVIDIA GB10 (DGX Spark)</a:t>
-            </a:r>
-          </a:p>
-          <a:p>
-            <a:pPr>
-              <a:spcAft>
-                <a:spcPts val="600"/>
-              </a:spcAft>
-              <a:defRPr sz="1400">
-                <a:solidFill>
-                  <a:srgbClr val="333333"/>
-                </a:solidFill>
-                <a:latin typeface="Calibri"/>
-              </a:defRPr>
-            </a:pPr>
-            <a:r>
-              <a:t>128 GB unified memory</a:t>
-            </a:r>
-          </a:p>
-          <a:p>
-            <a:pPr>
-              <a:spcAft>
-                <a:spcPts val="600"/>
-              </a:spcAft>
-              <a:defRPr sz="1400">
-                <a:solidFill>
-                  <a:srgbClr val="333333"/>
-                </a:solidFill>
-                <a:latin typeface="Calibri"/>
-              </a:defRPr>
-            </a:pPr>
-          </a:p>
-          <a:p>
-            <a:pPr>
-              <a:spcAft>
-                <a:spcPts val="600"/>
-              </a:spcAft>
-              <a:defRPr sz="1400">
-                <a:solidFill>
-                  <a:srgbClr val="333333"/>
-                </a:solidFill>
-                <a:latin typeface="Calibri"/>
-              </a:defRPr>
-            </a:pPr>
-            <a:r>
-              <a:t>FDTD stencil is inherently</a:t>
-            </a:r>
-          </a:p>
-          <a:p>
-            <a:pPr>
-              <a:spcAft>
-                <a:spcPts val="600"/>
-              </a:spcAft>
-              <a:defRPr sz="1400">
-                <a:solidFill>
-                  <a:srgbClr val="333333"/>
-                </a:solidFill>
-                <a:latin typeface="Calibri"/>
-              </a:defRPr>
-            </a:pPr>
-            <a:r>
-              <a:t>  parallel: 1 thread/cell</a:t>
-            </a:r>
-          </a:p>
-        </p:txBody>
-      </p:sp>
-      <p:sp>
-        <p:nvSpPr>
-          <p:cNvPr id="6" name="TextBox 5"/>
+            <a:pPr algn="ctr">
+              <a:defRPr sz="1600" b="1">
+                <a:solidFill>
+                  <a:srgbClr val="333333"/>
+                </a:solidFill>
+                <a:latin typeface="Calibri"/>
+              </a:defRPr>
+            </a:pPr>
+            <a:r>
+              <a:t>Observed</a:t>
+            </a:r>
+          </a:p>
+        </p:txBody>
+      </p:sp>
+      <p:pic>
+        <p:nvPicPr>
+          <p:cNvPr id="6" name="Picture 5" descr="bscan_inverted.png"/>
+          <p:cNvPicPr>
+            <a:picLocks noChangeAspect="1"/>
+          </p:cNvPicPr>
+          <p:nvPr/>
+        </p:nvPicPr>
+        <p:blipFill>
+          <a:blip r:embed="rId3"/>
+          <a:stretch>
+            <a:fillRect/>
+          </a:stretch>
+        </p:blipFill>
+        <p:spPr>
+          <a:xfrm>
+            <a:off x="4206240" y="1371600"/>
+            <a:ext cx="3749039" cy="2668632"/>
+          </a:xfrm>
+          <a:prstGeom prst="rect">
+            <a:avLst/>
+          </a:prstGeom>
+        </p:spPr>
+      </p:pic>
+      <p:sp>
+        <p:nvSpPr>
+          <p:cNvPr id="7" name="TextBox 6"/>
           <p:cNvSpPr txBox="1"/>
           <p:nvPr/>
         </p:nvSpPr>
         <p:spPr>
           <a:xfrm>
-            <a:off x="8686800" y="5029200"/>
-            <a:ext cx="2743200" cy="1097280"/>
+            <a:off x="4206240" y="1097280"/>
+            <a:ext cx="3749039" cy="365760"/>
           </a:xfrm>
           <a:prstGeom prst="rect">
             <a:avLst/>
@@ -7370,28 +7684,75 @@
           <a:lstStyle/>
           <a:p>
             <a:pPr algn="ctr">
-              <a:defRPr sz="3600" b="1">
-                <a:solidFill>
-                  <a:srgbClr val="2E7D32"/>
-                </a:solidFill>
-                <a:latin typeface="Calibri"/>
-              </a:defRPr>
-            </a:pPr>
-            <a:r>
-              <a:t>3-7x</a:t>
-            </a:r>
-          </a:p>
+              <a:defRPr sz="1600" b="1">
+                <a:solidFill>
+                  <a:srgbClr val="333333"/>
+                </a:solidFill>
+                <a:latin typeface="Calibri"/>
+              </a:defRPr>
+            </a:pPr>
+            <a:r>
+              <a:t>Inverted</a:t>
+            </a:r>
+          </a:p>
+        </p:txBody>
+      </p:sp>
+      <p:pic>
+        <p:nvPicPr>
+          <p:cNvPr id="8" name="Picture 7" descr="residual_bscan.png"/>
+          <p:cNvPicPr>
+            <a:picLocks noChangeAspect="1"/>
+          </p:cNvPicPr>
+          <p:nvPr/>
+        </p:nvPicPr>
+        <p:blipFill>
+          <a:blip r:embed="rId4"/>
+          <a:stretch>
+            <a:fillRect/>
+          </a:stretch>
+        </p:blipFill>
+        <p:spPr>
+          <a:xfrm>
+            <a:off x="8138160" y="1371600"/>
+            <a:ext cx="3749039" cy="2659442"/>
+          </a:xfrm>
+          <a:prstGeom prst="rect">
+            <a:avLst/>
+          </a:prstGeom>
+        </p:spPr>
+      </p:pic>
+      <p:sp>
+        <p:nvSpPr>
+          <p:cNvPr id="9" name="TextBox 8"/>
+          <p:cNvSpPr txBox="1"/>
+          <p:nvPr/>
+        </p:nvSpPr>
+        <p:spPr>
+          <a:xfrm>
+            <a:off x="8138160" y="1097280"/>
+            <a:ext cx="3749039" cy="365760"/>
+          </a:xfrm>
+          <a:prstGeom prst="rect">
+            <a:avLst/>
+          </a:prstGeom>
+          <a:noFill/>
+        </p:spPr>
+        <p:txBody>
+          <a:bodyPr wrap="square">
+            <a:spAutoFit/>
+          </a:bodyPr>
+          <a:lstStyle/>
           <a:p>
             <a:pPr algn="ctr">
-              <a:defRPr sz="1400">
-                <a:solidFill>
-                  <a:srgbClr val="333333"/>
-                </a:solidFill>
-                <a:latin typeface="Calibri"/>
-              </a:defRPr>
-            </a:pPr>
-            <a:r>
-              <a:t>speedup</a:t>
+              <a:defRPr sz="1600" b="1">
+                <a:solidFill>
+                  <a:srgbClr val="333333"/>
+                </a:solidFill>
+                <a:latin typeface="Calibri"/>
+              </a:defRPr>
+            </a:pPr>
+            <a:r>
+              <a:t>Residual</a:t>
             </a:r>
           </a:p>
         </p:txBody>
@@ -7488,21 +7849,45 @@
               </a:defRPr>
             </a:pPr>
             <a:r>
-              <a:t>Extension: GPU CPML (Full GPU Time-Stepping)</a:t>
-            </a:r>
-          </a:p>
-        </p:txBody>
-      </p:sp>
-      <p:sp>
-        <p:nvSpPr>
-          <p:cNvPr id="4" name="TextBox 3"/>
+              <a:t>GPU Acceleration: Measured Benchmarks</a:t>
+            </a:r>
+          </a:p>
+        </p:txBody>
+      </p:sp>
+      <p:pic>
+        <p:nvPicPr>
+          <p:cNvPr id="4" name="Picture 3" descr="gpu_scaling.png"/>
+          <p:cNvPicPr>
+            <a:picLocks noChangeAspect="1"/>
+          </p:cNvPicPr>
+          <p:nvPr/>
+        </p:nvPicPr>
+        <p:blipFill>
+          <a:blip r:embed="rId2"/>
+          <a:stretch>
+            <a:fillRect/>
+          </a:stretch>
+        </p:blipFill>
+        <p:spPr>
+          <a:xfrm>
+            <a:off x="274320" y="1097280"/>
+            <a:ext cx="7772400" cy="2719033"/>
+          </a:xfrm>
+          <a:prstGeom prst="rect">
+            <a:avLst/>
+          </a:prstGeom>
+        </p:spPr>
+      </p:pic>
+      <p:sp>
+        <p:nvSpPr>
+          <p:cNvPr id="5" name="TextBox 4"/>
           <p:cNvSpPr txBox="1"/>
           <p:nvPr/>
         </p:nvSpPr>
         <p:spPr>
           <a:xfrm>
-            <a:off x="457200" y="1371600"/>
-            <a:ext cx="10972800" cy="4572000"/>
+            <a:off x="8229600" y="1371600"/>
+            <a:ext cx="3657600" cy="4572000"/>
           </a:xfrm>
           <a:prstGeom prst="rect">
             <a:avLst/>
@@ -7519,15 +7904,15 @@
               <a:spcAft>
                 <a:spcPts val="600"/>
               </a:spcAft>
-              <a:defRPr sz="1700">
-                <a:solidFill>
-                  <a:srgbClr val="333333"/>
-                </a:solidFill>
-                <a:latin typeface="Calibri"/>
-              </a:defRPr>
-            </a:pPr>
-            <a:r>
-              <a:t>Ported all 8 PML boundary corrections to GPU (CuPy vectorised ops)</a:t>
+              <a:defRPr sz="1400">
+                <a:solidFill>
+                  <a:srgbClr val="333333"/>
+                </a:solidFill>
+                <a:latin typeface="Calibri"/>
+              </a:defRPr>
+            </a:pPr>
+            <a:r>
+              <a:t>Measured on NVIDIA GB10</a:t>
             </a:r>
           </a:p>
           <a:p>
@@ -7535,15 +7920,15 @@
               <a:spcAft>
                 <a:spcPts val="600"/>
               </a:spcAft>
-              <a:defRPr sz="1700">
-                <a:solidFill>
-                  <a:srgbClr val="333333"/>
-                </a:solidFill>
-                <a:latin typeface="Calibri"/>
-              </a:defRPr>
-            </a:pPr>
-            <a:r>
-              <a:t>Replaced per-layer Python loops with 2D array broadcasting</a:t>
+              <a:defRPr sz="1400">
+                <a:solidFill>
+                  <a:srgbClr val="333333"/>
+                </a:solidFill>
+                <a:latin typeface="Calibri"/>
+              </a:defRPr>
+            </a:pPr>
+            <a:r>
+              <a:t>(DGX Spark, 128 GB)</a:t>
             </a:r>
           </a:p>
           <a:p>
@@ -7551,44 +7936,44 @@
               <a:spcAft>
                 <a:spcPts val="600"/>
               </a:spcAft>
-              <a:defRPr sz="1700">
-                <a:solidFill>
-                  <a:srgbClr val="333333"/>
-                </a:solidFill>
-                <a:latin typeface="Calibri"/>
-              </a:defRPr>
-            </a:pPr>
-            <a:r>
-              <a:t>All psi auxiliary arrays reside on GPU — no CPU-GPU transfers during stepping</a:t>
-            </a:r>
+              <a:defRPr sz="1400">
+                <a:solidFill>
+                  <a:srgbClr val="333333"/>
+                </a:solidFill>
+                <a:latin typeface="Calibri"/>
+              </a:defRPr>
+            </a:pPr>
           </a:p>
           <a:p>
             <a:pPr>
               <a:spcAft>
                 <a:spcPts val="600"/>
               </a:spcAft>
-              <a:defRPr sz="1700">
-                <a:solidFill>
-                  <a:srgbClr val="333333"/>
-                </a:solidFill>
-                <a:latin typeface="Calibri"/>
-              </a:defRPr>
-            </a:pPr>
+              <a:defRPr sz="1400">
+                <a:solidFill>
+                  <a:srgbClr val="333333"/>
+                </a:solidFill>
+                <a:latin typeface="Calibri"/>
+              </a:defRPr>
+            </a:pPr>
+            <a:r>
+              <a:t>5 grid sizes benchmarked:</a:t>
+            </a:r>
           </a:p>
           <a:p>
             <a:pPr>
               <a:spcAft>
                 <a:spcPts val="600"/>
               </a:spcAft>
-              <a:defRPr sz="1700">
-                <a:solidFill>
-                  <a:srgbClr val="333333"/>
-                </a:solidFill>
-                <a:latin typeface="Calibri"/>
-              </a:defRPr>
-            </a:pPr>
-            <a:r>
-              <a:t>Verification: bit-identical traces vs CPU reference (zero error at float64)</a:t>
+              <a:defRPr sz="1400">
+                <a:solidFill>
+                  <a:srgbClr val="333333"/>
+                </a:solidFill>
+                <a:latin typeface="Calibri"/>
+              </a:defRPr>
+            </a:pPr>
+            <a:r>
+              <a:t>  50K → 3.2M cells</a:t>
             </a:r>
           </a:p>
           <a:p>
@@ -7596,41 +7981,150 @@
               <a:spcAft>
                 <a:spcPts val="600"/>
               </a:spcAft>
-              <a:defRPr sz="1700">
-                <a:solidFill>
-                  <a:srgbClr val="333333"/>
-                </a:solidFill>
-                <a:latin typeface="Calibri"/>
-              </a:defRPr>
-            </a:pPr>
+              <a:defRPr sz="1400">
+                <a:solidFill>
+                  <a:srgbClr val="333333"/>
+                </a:solidFill>
+                <a:latin typeface="Calibri"/>
+              </a:defRPr>
+            </a:pPr>
+            <a:r>
+              <a:t>  500 time steps each</a:t>
+            </a:r>
           </a:p>
           <a:p>
             <a:pPr>
               <a:spcAft>
                 <a:spcPts val="600"/>
               </a:spcAft>
-              <a:defRPr sz="1700">
-                <a:solidFill>
-                  <a:srgbClr val="333333"/>
-                </a:solidFill>
-                <a:latin typeface="Calibri"/>
-              </a:defRPr>
-            </a:pPr>
-            <a:r>
-              <a:t>Result: complete GPU-resident FDTD loop (H update + CPML + E update + CPML + source)</a:t>
-            </a:r>
-          </a:p>
-        </p:txBody>
-      </p:sp>
-      <p:sp>
-        <p:nvSpPr>
-          <p:cNvPr id="5" name="TextBox 4"/>
+              <a:defRPr sz="1400">
+                <a:solidFill>
+                  <a:srgbClr val="333333"/>
+                </a:solidFill>
+                <a:latin typeface="Calibri"/>
+              </a:defRPr>
+            </a:pPr>
+            <a:r>
+              <a:t>  2 runs averaged</a:t>
+            </a:r>
+          </a:p>
+          <a:p>
+            <a:pPr>
+              <a:spcAft>
+                <a:spcPts val="600"/>
+              </a:spcAft>
+              <a:defRPr sz="1400">
+                <a:solidFill>
+                  <a:srgbClr val="333333"/>
+                </a:solidFill>
+                <a:latin typeface="Calibri"/>
+              </a:defRPr>
+            </a:pPr>
+          </a:p>
+          <a:p>
+            <a:pPr>
+              <a:spcAft>
+                <a:spcPts val="600"/>
+              </a:spcAft>
+              <a:defRPr sz="1400">
+                <a:solidFill>
+                  <a:srgbClr val="333333"/>
+                </a:solidFill>
+                <a:latin typeface="Calibri"/>
+              </a:defRPr>
+            </a:pPr>
+            <a:r>
+              <a:t>CuPy: drop-in NumPy</a:t>
+            </a:r>
+          </a:p>
+          <a:p>
+            <a:pPr>
+              <a:spcAft>
+                <a:spcPts val="600"/>
+              </a:spcAft>
+              <a:defRPr sz="1400">
+                <a:solidFill>
+                  <a:srgbClr val="333333"/>
+                </a:solidFill>
+                <a:latin typeface="Calibri"/>
+              </a:defRPr>
+            </a:pPr>
+            <a:r>
+              <a:t>replacement for CUDA</a:t>
+            </a:r>
+          </a:p>
+          <a:p>
+            <a:pPr>
+              <a:spcAft>
+                <a:spcPts val="600"/>
+              </a:spcAft>
+              <a:defRPr sz="1400">
+                <a:solidFill>
+                  <a:srgbClr val="333333"/>
+                </a:solidFill>
+                <a:latin typeface="Calibri"/>
+              </a:defRPr>
+            </a:pPr>
+          </a:p>
+          <a:p>
+            <a:pPr>
+              <a:spcAft>
+                <a:spcPts val="600"/>
+              </a:spcAft>
+              <a:defRPr sz="1400">
+                <a:solidFill>
+                  <a:srgbClr val="333333"/>
+                </a:solidFill>
+                <a:latin typeface="Calibri"/>
+              </a:defRPr>
+            </a:pPr>
+            <a:r>
+              <a:t>Speedup increases with</a:t>
+            </a:r>
+          </a:p>
+          <a:p>
+            <a:pPr>
+              <a:spcAft>
+                <a:spcPts val="600"/>
+              </a:spcAft>
+              <a:defRPr sz="1400">
+                <a:solidFill>
+                  <a:srgbClr val="333333"/>
+                </a:solidFill>
+                <a:latin typeface="Calibri"/>
+              </a:defRPr>
+            </a:pPr>
+            <a:r>
+              <a:t>grid size (more parallel</a:t>
+            </a:r>
+          </a:p>
+          <a:p>
+            <a:pPr>
+              <a:spcAft>
+                <a:spcPts val="600"/>
+              </a:spcAft>
+              <a:defRPr sz="1400">
+                <a:solidFill>
+                  <a:srgbClr val="333333"/>
+                </a:solidFill>
+                <a:latin typeface="Calibri"/>
+              </a:defRPr>
+            </a:pPr>
+            <a:r>
+              <a:t>work saturates GPU)</a:t>
+            </a:r>
+          </a:p>
+        </p:txBody>
+      </p:sp>
+      <p:sp>
+        <p:nvSpPr>
+          <p:cNvPr id="6" name="TextBox 5"/>
           <p:cNvSpPr txBox="1"/>
           <p:nvPr/>
         </p:nvSpPr>
         <p:spPr>
           <a:xfrm>
-            <a:off x="8686800" y="4572000"/>
+            <a:off x="8686800" y="5029200"/>
             <a:ext cx="2743200" cy="1097280"/>
           </a:xfrm>
           <a:prstGeom prst="rect">
@@ -7653,7 +8147,7 @@
               </a:defRPr>
             </a:pPr>
             <a:r>
-              <a:t>Bit-identical</a:t>
+              <a:t>3.2-7.0x</a:t>
             </a:r>
           </a:p>
           <a:p>
@@ -7666,7 +8160,7 @@
               </a:defRPr>
             </a:pPr>
             <a:r>
-              <a:t>to CPU</a:t>
+              <a:t>measured speedup</a:t>
             </a:r>
           </a:p>
         </p:txBody>
@@ -7763,45 +8257,21 @@
               </a:defRPr>
             </a:pPr>
             <a:r>
-              <a:t>Extension: Dispersive Materials (Debye Model)</a:t>
-            </a:r>
-          </a:p>
-        </p:txBody>
-      </p:sp>
-      <p:pic>
-        <p:nvPicPr>
-          <p:cNvPr id="4" name="Picture 3" descr="dispersive_comparison.png"/>
-          <p:cNvPicPr>
-            <a:picLocks noChangeAspect="1"/>
-          </p:cNvPicPr>
-          <p:nvPr/>
-        </p:nvPicPr>
-        <p:blipFill>
-          <a:blip r:embed="rId2"/>
-          <a:stretch>
-            <a:fillRect/>
-          </a:stretch>
-        </p:blipFill>
-        <p:spPr>
-          <a:xfrm>
-            <a:off x="274320" y="1097280"/>
-            <a:ext cx="7315200" cy="3627954"/>
-          </a:xfrm>
-          <a:prstGeom prst="rect">
-            <a:avLst/>
-          </a:prstGeom>
-        </p:spPr>
-      </p:pic>
-      <p:sp>
-        <p:nvSpPr>
-          <p:cNvPr id="5" name="TextBox 4"/>
+              <a:t>Extension: GPU CPML (Full GPU Time-Stepping)</a:t>
+            </a:r>
+          </a:p>
+        </p:txBody>
+      </p:sp>
+      <p:sp>
+        <p:nvSpPr>
+          <p:cNvPr id="4" name="TextBox 3"/>
           <p:cNvSpPr txBox="1"/>
           <p:nvPr/>
         </p:nvSpPr>
         <p:spPr>
           <a:xfrm>
-            <a:off x="7772400" y="1371600"/>
-            <a:ext cx="4114800" cy="3657600"/>
+            <a:off x="457200" y="1371600"/>
+            <a:ext cx="10972800" cy="4572000"/>
           </a:xfrm>
           <a:prstGeom prst="rect">
             <a:avLst/>
@@ -7818,15 +8288,15 @@
               <a:spcAft>
                 <a:spcPts val="600"/>
               </a:spcAft>
-              <a:defRPr sz="1400">
-                <a:solidFill>
-                  <a:srgbClr val="333333"/>
-                </a:solidFill>
-                <a:latin typeface="Calibri"/>
-              </a:defRPr>
-            </a:pPr>
-            <a:r>
-              <a:t>Single-pole Debye ADE</a:t>
+              <a:defRPr sz="1500">
+                <a:solidFill>
+                  <a:srgbClr val="333333"/>
+                </a:solidFill>
+                <a:latin typeface="Calibri"/>
+              </a:defRPr>
+            </a:pPr>
+            <a:r>
+              <a:t>Ported all 8 PML boundary corrections to GPU (CuPy vectorised ops)</a:t>
             </a:r>
           </a:p>
           <a:p>
@@ -7834,15 +8304,15 @@
               <a:spcAft>
                 <a:spcPts val="600"/>
               </a:spcAft>
-              <a:defRPr sz="1400">
-                <a:solidFill>
-                  <a:srgbClr val="333333"/>
-                </a:solidFill>
-                <a:latin typeface="Calibri"/>
-              </a:defRPr>
-            </a:pPr>
-            <a:r>
-              <a:t>eps_inf=5.0, eps_s=7.0</a:t>
+              <a:defRPr sz="1500">
+                <a:solidFill>
+                  <a:srgbClr val="333333"/>
+                </a:solidFill>
+                <a:latin typeface="Calibri"/>
+              </a:defRPr>
+            </a:pPr>
+            <a:r>
+              <a:t>Replaced per-layer Python loops with 2D array broadcasting</a:t>
             </a:r>
           </a:p>
           <a:p>
@@ -7850,15 +8320,15 @@
               <a:spcAft>
                 <a:spcPts val="600"/>
               </a:spcAft>
-              <a:defRPr sz="1400">
-                <a:solidFill>
-                  <a:srgbClr val="333333"/>
-                </a:solidFill>
-                <a:latin typeface="Calibri"/>
-              </a:defRPr>
-            </a:pPr>
-            <a:r>
-              <a:t>tau = 0.1 ns</a:t>
+              <a:defRPr sz="1500">
+                <a:solidFill>
+                  <a:srgbClr val="333333"/>
+                </a:solidFill>
+                <a:latin typeface="Calibri"/>
+              </a:defRPr>
+            </a:pPr>
+            <a:r>
+              <a:t>All psi arrays on GPU — complete GPU-resident time-stepping loop</a:t>
             </a:r>
           </a:p>
           <a:p>
@@ -7866,7 +8336,7 @@
               <a:spcAft>
                 <a:spcPts val="600"/>
               </a:spcAft>
-              <a:defRPr sz="1400">
+              <a:defRPr sz="1500">
                 <a:solidFill>
                   <a:srgbClr val="333333"/>
                 </a:solidFill>
@@ -7879,15 +8349,15 @@
               <a:spcAft>
                 <a:spcPts val="600"/>
               </a:spcAft>
-              <a:defRPr sz="1400">
-                <a:solidFill>
-                  <a:srgbClr val="333333"/>
-                </a:solidFill>
-                <a:latin typeface="Calibri"/>
-              </a:defRPr>
-            </a:pPr>
-            <a:r>
-              <a:t>Adds polarisation current</a:t>
+              <a:defRPr sz="1500">
+                <a:solidFill>
+                  <a:srgbClr val="333333"/>
+                </a:solidFill>
+                <a:latin typeface="Calibri"/>
+              </a:defRPr>
+            </a:pPr>
+            <a:r>
+              <a:t>Verification: bit-identical traces vs CPU (zero error at float64 precision)</a:t>
             </a:r>
           </a:p>
           <a:p>
@@ -7895,44 +8365,44 @@
               <a:spcAft>
                 <a:spcPts val="600"/>
               </a:spcAft>
-              <a:defRPr sz="1400">
-                <a:solidFill>
-                  <a:srgbClr val="333333"/>
-                </a:solidFill>
-                <a:latin typeface="Calibri"/>
-              </a:defRPr>
-            </a:pPr>
-            <a:r>
-              <a:t>to E-field update</a:t>
-            </a:r>
+              <a:defRPr sz="1500">
+                <a:solidFill>
+                  <a:srgbClr val="333333"/>
+                </a:solidFill>
+                <a:latin typeface="Calibri"/>
+              </a:defRPr>
+            </a:pPr>
           </a:p>
           <a:p>
             <a:pPr>
               <a:spcAft>
                 <a:spcPts val="600"/>
               </a:spcAft>
-              <a:defRPr sz="1400">
-                <a:solidFill>
-                  <a:srgbClr val="333333"/>
-                </a:solidFill>
-                <a:latin typeface="Calibri"/>
-              </a:defRPr>
-            </a:pPr>
+              <a:defRPr sz="1500">
+                <a:solidFill>
+                  <a:srgbClr val="333333"/>
+                </a:solidFill>
+                <a:latin typeface="Calibri"/>
+              </a:defRPr>
+            </a:pPr>
+            <a:r>
+              <a:t>Performance at project grid (180x280):</a:t>
+            </a:r>
           </a:p>
           <a:p>
             <a:pPr>
               <a:spcAft>
                 <a:spcPts val="600"/>
               </a:spcAft>
-              <a:defRPr sz="1400">
-                <a:solidFill>
-                  <a:srgbClr val="333333"/>
-                </a:solidFill>
-                <a:latin typeface="Calibri"/>
-              </a:defRPr>
-            </a:pPr>
-            <a:r>
-              <a:t>Significant for quantitative</a:t>
+              <a:defRPr sz="1500">
+                <a:solidFill>
+                  <a:srgbClr val="333333"/>
+                </a:solidFill>
+                <a:latin typeface="Calibri"/>
+              </a:defRPr>
+            </a:pPr>
+            <a:r>
+              <a:t>  CPU with CPML: 1.70 s    |    GPU v2 with CPML: 1.10 s    →   1.5x speedup</a:t>
             </a:r>
           </a:p>
           <a:p>
@@ -7940,22 +8410,83 @@
               <a:spcAft>
                 <a:spcPts val="600"/>
               </a:spcAft>
-              <a:defRPr sz="1400">
-                <a:solidFill>
-                  <a:srgbClr val="333333"/>
-                </a:solidFill>
-                <a:latin typeface="Calibri"/>
-              </a:defRPr>
-            </a:pPr>
-            <a:r>
-              <a:t>FWI with real data</a:t>
-            </a:r>
-          </a:p>
-        </p:txBody>
-      </p:sp>
-      <p:sp>
-        <p:nvSpPr>
-          <p:cNvPr id="6" name="TextBox 5"/>
+              <a:defRPr sz="1500">
+                <a:solidFill>
+                  <a:srgbClr val="333333"/>
+                </a:solidFill>
+                <a:latin typeface="Calibri"/>
+              </a:defRPr>
+            </a:pPr>
+          </a:p>
+          <a:p>
+            <a:pPr>
+              <a:spcAft>
+                <a:spcPts val="600"/>
+              </a:spcAft>
+              <a:defRPr sz="1500">
+                <a:solidFill>
+                  <a:srgbClr val="333333"/>
+                </a:solidFill>
+                <a:latin typeface="Calibri"/>
+              </a:defRPr>
+            </a:pPr>
+            <a:r>
+              <a:t>Why modest speedup? CPML operates on thin boundary strips (15 cells wide)</a:t>
+            </a:r>
+          </a:p>
+          <a:p>
+            <a:pPr>
+              <a:spcAft>
+                <a:spcPts val="600"/>
+              </a:spcAft>
+              <a:defRPr sz="1500">
+                <a:solidFill>
+                  <a:srgbClr val="333333"/>
+                </a:solidFill>
+                <a:latin typeface="Calibri"/>
+              </a:defRPr>
+            </a:pPr>
+            <a:r>
+              <a:t>  — low parallelism per kernel launch. At larger grids (e.g., 3D with</a:t>
+            </a:r>
+          </a:p>
+          <a:p>
+            <a:pPr>
+              <a:spcAft>
+                <a:spcPts val="600"/>
+              </a:spcAft>
+              <a:defRPr sz="1500">
+                <a:solidFill>
+                  <a:srgbClr val="333333"/>
+                </a:solidFill>
+                <a:latin typeface="Calibri"/>
+              </a:defRPr>
+            </a:pPr>
+            <a:r>
+              <a:t>  millions of cells), the field-update cost dominates and overall GPU</a:t>
+            </a:r>
+          </a:p>
+          <a:p>
+            <a:pPr>
+              <a:spcAft>
+                <a:spcPts val="600"/>
+              </a:spcAft>
+              <a:defRPr sz="1500">
+                <a:solidFill>
+                  <a:srgbClr val="333333"/>
+                </a:solidFill>
+                <a:latin typeface="Calibri"/>
+              </a:defRPr>
+            </a:pPr>
+            <a:r>
+              <a:t>  speedup approaches the 3-7x measured for field updates alone.</a:t>
+            </a:r>
+          </a:p>
+        </p:txBody>
+      </p:sp>
+      <p:sp>
+        <p:nvSpPr>
+          <p:cNvPr id="5" name="TextBox 4"/>
           <p:cNvSpPr txBox="1"/>
           <p:nvPr/>
         </p:nvSpPr>
@@ -7984,7 +8515,7 @@
               </a:defRPr>
             </a:pPr>
             <a:r>
-              <a:t>~20%</a:t>
+              <a:t>Bit-identical</a:t>
             </a:r>
           </a:p>
           <a:p>
@@ -7997,7 +8528,7 @@
               </a:defRPr>
             </a:pPr>
             <a:r>
-              <a:t>trace effect</a:t>
+              <a:t>to CPU</a:t>
             </a:r>
           </a:p>
         </p:txBody>
@@ -8389,14 +8920,14 @@
               </a:defRPr>
             </a:pPr>
             <a:r>
-              <a:t>Extension: Distributed Dipole Antenna Model</a:t>
+              <a:t>Extension: Dispersive Materials (Debye Model)</a:t>
             </a:r>
           </a:p>
         </p:txBody>
       </p:sp>
       <p:pic>
         <p:nvPicPr>
-          <p:cNvPr id="4" name="Picture 3" descr="antenna_comparison.png"/>
+          <p:cNvPr id="4" name="Picture 3" descr="dispersive_comparison.png"/>
           <p:cNvPicPr>
             <a:picLocks noChangeAspect="1"/>
           </p:cNvPicPr>
@@ -8411,7 +8942,7 @@
         <p:spPr>
           <a:xfrm>
             <a:off x="274320" y="1097280"/>
-            <a:ext cx="11430000" cy="4235775"/>
+            <a:ext cx="7315200" cy="3627954"/>
           </a:xfrm>
           <a:prstGeom prst="rect">
             <a:avLst/>
@@ -8426,8 +8957,8 @@
         </p:nvSpPr>
         <p:spPr>
           <a:xfrm>
-            <a:off x="9144000" y="5029200"/>
-            <a:ext cx="2743200" cy="1097280"/>
+            <a:off x="7772400" y="1371600"/>
+            <a:ext cx="4114800" cy="3657600"/>
           </a:xfrm>
           <a:prstGeom prst="rect">
             <a:avLst/>
@@ -8440,6 +8971,167 @@
           </a:bodyPr>
           <a:lstStyle/>
           <a:p>
+            <a:pPr>
+              <a:spcAft>
+                <a:spcPts val="600"/>
+              </a:spcAft>
+              <a:defRPr sz="1400">
+                <a:solidFill>
+                  <a:srgbClr val="333333"/>
+                </a:solidFill>
+                <a:latin typeface="Calibri"/>
+              </a:defRPr>
+            </a:pPr>
+            <a:r>
+              <a:t>Single-pole Debye ADE</a:t>
+            </a:r>
+          </a:p>
+          <a:p>
+            <a:pPr>
+              <a:spcAft>
+                <a:spcPts val="600"/>
+              </a:spcAft>
+              <a:defRPr sz="1400">
+                <a:solidFill>
+                  <a:srgbClr val="333333"/>
+                </a:solidFill>
+                <a:latin typeface="Calibri"/>
+              </a:defRPr>
+            </a:pPr>
+            <a:r>
+              <a:t>eps_inf=5.0, eps_s=7.0</a:t>
+            </a:r>
+          </a:p>
+          <a:p>
+            <a:pPr>
+              <a:spcAft>
+                <a:spcPts val="600"/>
+              </a:spcAft>
+              <a:defRPr sz="1400">
+                <a:solidFill>
+                  <a:srgbClr val="333333"/>
+                </a:solidFill>
+                <a:latin typeface="Calibri"/>
+              </a:defRPr>
+            </a:pPr>
+            <a:r>
+              <a:t>tau = 0.1 ns</a:t>
+            </a:r>
+          </a:p>
+          <a:p>
+            <a:pPr>
+              <a:spcAft>
+                <a:spcPts val="600"/>
+              </a:spcAft>
+              <a:defRPr sz="1400">
+                <a:solidFill>
+                  <a:srgbClr val="333333"/>
+                </a:solidFill>
+                <a:latin typeface="Calibri"/>
+              </a:defRPr>
+            </a:pPr>
+          </a:p>
+          <a:p>
+            <a:pPr>
+              <a:spcAft>
+                <a:spcPts val="600"/>
+              </a:spcAft>
+              <a:defRPr sz="1400">
+                <a:solidFill>
+                  <a:srgbClr val="333333"/>
+                </a:solidFill>
+                <a:latin typeface="Calibri"/>
+              </a:defRPr>
+            </a:pPr>
+            <a:r>
+              <a:t>Adds polarisation current</a:t>
+            </a:r>
+          </a:p>
+          <a:p>
+            <a:pPr>
+              <a:spcAft>
+                <a:spcPts val="600"/>
+              </a:spcAft>
+              <a:defRPr sz="1400">
+                <a:solidFill>
+                  <a:srgbClr val="333333"/>
+                </a:solidFill>
+                <a:latin typeface="Calibri"/>
+              </a:defRPr>
+            </a:pPr>
+            <a:r>
+              <a:t>to E-field update</a:t>
+            </a:r>
+          </a:p>
+          <a:p>
+            <a:pPr>
+              <a:spcAft>
+                <a:spcPts val="600"/>
+              </a:spcAft>
+              <a:defRPr sz="1400">
+                <a:solidFill>
+                  <a:srgbClr val="333333"/>
+                </a:solidFill>
+                <a:latin typeface="Calibri"/>
+              </a:defRPr>
+            </a:pPr>
+          </a:p>
+          <a:p>
+            <a:pPr>
+              <a:spcAft>
+                <a:spcPts val="600"/>
+              </a:spcAft>
+              <a:defRPr sz="1400">
+                <a:solidFill>
+                  <a:srgbClr val="333333"/>
+                </a:solidFill>
+                <a:latin typeface="Calibri"/>
+              </a:defRPr>
+            </a:pPr>
+            <a:r>
+              <a:t>Significant for quantitative</a:t>
+            </a:r>
+          </a:p>
+          <a:p>
+            <a:pPr>
+              <a:spcAft>
+                <a:spcPts val="600"/>
+              </a:spcAft>
+              <a:defRPr sz="1400">
+                <a:solidFill>
+                  <a:srgbClr val="333333"/>
+                </a:solidFill>
+                <a:latin typeface="Calibri"/>
+              </a:defRPr>
+            </a:pPr>
+            <a:r>
+              <a:t>FWI with real data</a:t>
+            </a:r>
+          </a:p>
+        </p:txBody>
+      </p:sp>
+      <p:sp>
+        <p:nvSpPr>
+          <p:cNvPr id="6" name="TextBox 5"/>
+          <p:cNvSpPr txBox="1"/>
+          <p:nvPr/>
+        </p:nvSpPr>
+        <p:spPr>
+          <a:xfrm>
+            <a:off x="8686800" y="5029200"/>
+            <a:ext cx="2743200" cy="1097280"/>
+          </a:xfrm>
+          <a:prstGeom prst="rect">
+            <a:avLst/>
+          </a:prstGeom>
+          <a:noFill/>
+        </p:spPr>
+        <p:txBody>
+          <a:bodyPr wrap="square">
+            <a:spAutoFit/>
+          </a:bodyPr>
+          <a:lstStyle/>
+          <a:p>
             <a:pPr algn="ctr">
               <a:defRPr sz="3600" b="1">
                 <a:solidFill>
@@ -8449,7 +9141,7 @@
               </a:defRPr>
             </a:pPr>
             <a:r>
-              <a:t>~40%</a:t>
+              <a:t>~20%</a:t>
             </a:r>
           </a:p>
           <a:p>
@@ -8462,7 +9154,7 @@
               </a:defRPr>
             </a:pPr>
             <a:r>
-              <a:t>amplitude effect</a:t>
+              <a:t>trace effect</a:t>
             </a:r>
           </a:p>
         </p:txBody>
@@ -8559,14 +9251,14 @@
               </a:defRPr>
             </a:pPr>
             <a:r>
-              <a:t>Extension: Multi-Scale Frequency Continuation</a:t>
+              <a:t>Extension: Distributed Dipole Antenna Model</a:t>
             </a:r>
           </a:p>
         </p:txBody>
       </p:sp>
       <p:pic>
         <p:nvPicPr>
-          <p:cNvPr id="4" name="Picture 3" descr="multiscale_bar.png"/>
+          <p:cNvPr id="4" name="Picture 3" descr="antenna_comparison.png"/>
           <p:cNvPicPr>
             <a:picLocks noChangeAspect="1"/>
           </p:cNvPicPr>
@@ -8581,7 +9273,7 @@
         <p:spPr>
           <a:xfrm>
             <a:off x="274320" y="1097280"/>
-            <a:ext cx="11430000" cy="4553379"/>
+            <a:ext cx="11430000" cy="4235775"/>
           </a:xfrm>
           <a:prstGeom prst="rect">
             <a:avLst/>
@@ -8596,8 +9288,8 @@
         </p:nvSpPr>
         <p:spPr>
           <a:xfrm>
-            <a:off x="914400" y="5760720"/>
-            <a:ext cx="10058400" cy="457200"/>
+            <a:off x="9144000" y="5029200"/>
+            <a:ext cx="2743200" cy="1097280"/>
           </a:xfrm>
           <a:prstGeom prst="rect">
             <a:avLst/>
@@ -8611,15 +9303,28 @@
           <a:lstStyle/>
           <a:p>
             <a:pPr algn="ctr">
-              <a:defRPr sz="1500" b="0">
-                <a:solidFill>
-                  <a:srgbClr val="333333"/>
-                </a:solidFill>
-                <a:latin typeface="Calibri"/>
-              </a:defRPr>
-            </a:pPr>
-            <a:r>
-              <a:t>Progressive refinement: 0.5 GHz (coarse) → 1.0 GHz (medium) → 1.5 GHz (fine)</a:t>
+              <a:defRPr sz="3600" b="1">
+                <a:solidFill>
+                  <a:srgbClr val="2E7D32"/>
+                </a:solidFill>
+                <a:latin typeface="Calibri"/>
+              </a:defRPr>
+            </a:pPr>
+            <a:r>
+              <a:t>~40%</a:t>
+            </a:r>
+          </a:p>
+          <a:p>
+            <a:pPr algn="ctr">
+              <a:defRPr sz="1400">
+                <a:solidFill>
+                  <a:srgbClr val="333333"/>
+                </a:solidFill>
+                <a:latin typeface="Calibri"/>
+              </a:defRPr>
+            </a:pPr>
+            <a:r>
+              <a:t>amplitude effect</a:t>
             </a:r>
           </a:p>
         </p:txBody>
@@ -8716,21 +9421,45 @@
               </a:defRPr>
             </a:pPr>
             <a:r>
-              <a:t>Software Architecture</a:t>
-            </a:r>
-          </a:p>
-        </p:txBody>
-      </p:sp>
-      <p:sp>
-        <p:nvSpPr>
-          <p:cNvPr id="4" name="TextBox 3"/>
+              <a:t>Extension: Multi-Scale Frequency Continuation</a:t>
+            </a:r>
+          </a:p>
+        </p:txBody>
+      </p:sp>
+      <p:pic>
+        <p:nvPicPr>
+          <p:cNvPr id="4" name="Picture 3" descr="multiscale_bar.png"/>
+          <p:cNvPicPr>
+            <a:picLocks noChangeAspect="1"/>
+          </p:cNvPicPr>
+          <p:nvPr/>
+        </p:nvPicPr>
+        <p:blipFill>
+          <a:blip r:embed="rId2"/>
+          <a:stretch>
+            <a:fillRect/>
+          </a:stretch>
+        </p:blipFill>
+        <p:spPr>
+          <a:xfrm>
+            <a:off x="274320" y="1097280"/>
+            <a:ext cx="11430000" cy="4553379"/>
+          </a:xfrm>
+          <a:prstGeom prst="rect">
+            <a:avLst/>
+          </a:prstGeom>
+        </p:spPr>
+      </p:pic>
+      <p:sp>
+        <p:nvSpPr>
+          <p:cNvPr id="5" name="TextBox 4"/>
           <p:cNvSpPr txBox="1"/>
           <p:nvPr/>
         </p:nvSpPr>
         <p:spPr>
           <a:xfrm>
-            <a:off x="914400" y="1463040"/>
-            <a:ext cx="2743200" cy="457200"/>
+            <a:off x="914400" y="5760720"/>
+            <a:ext cx="10058400" cy="457200"/>
           </a:xfrm>
           <a:prstGeom prst="rect">
             <a:avLst/>
@@ -8743,389 +9472,16 @@
           </a:bodyPr>
           <a:lstStyle/>
           <a:p>
-            <a:pPr algn="l">
-              <a:defRPr sz="2000" b="1">
-                <a:solidFill>
-                  <a:srgbClr val="1B3A5C"/>
-                </a:solidFill>
-                <a:latin typeface="Calibri"/>
-              </a:defRPr>
-            </a:pPr>
-            <a:r>
-              <a:t>core/</a:t>
-            </a:r>
-          </a:p>
-        </p:txBody>
-      </p:sp>
-      <p:sp>
-        <p:nvSpPr>
-          <p:cNvPr id="5" name="TextBox 4"/>
-          <p:cNvSpPr txBox="1"/>
-          <p:nvPr/>
-        </p:nvSpPr>
-        <p:spPr>
-          <a:xfrm>
-            <a:off x="3657600" y="1463040"/>
-            <a:ext cx="7315200" cy="457200"/>
-          </a:xfrm>
-          <a:prstGeom prst="rect">
-            <a:avLst/>
-          </a:prstGeom>
-          <a:noFill/>
-        </p:spPr>
-        <p:txBody>
-          <a:bodyPr wrap="square">
-            <a:spAutoFit/>
-          </a:bodyPr>
-          <a:lstStyle/>
-          <a:p>
-            <a:pPr algn="l">
-              <a:defRPr sz="1600" b="0">
-                <a:solidFill>
-                  <a:srgbClr val="333333"/>
-                </a:solidFill>
-                <a:latin typeface="Calibri"/>
-              </a:defRPr>
-            </a:pPr>
-            <a:r>
-              <a:t>FDTD engine, CPML, materials, geometry, source, scan</a:t>
-            </a:r>
-          </a:p>
-        </p:txBody>
-      </p:sp>
-      <p:sp>
-        <p:nvSpPr>
-          <p:cNvPr id="6" name="TextBox 5"/>
-          <p:cNvSpPr txBox="1"/>
-          <p:nvPr/>
-        </p:nvSpPr>
-        <p:spPr>
-          <a:xfrm>
-            <a:off x="914400" y="2240280"/>
-            <a:ext cx="2743200" cy="457200"/>
-          </a:xfrm>
-          <a:prstGeom prst="rect">
-            <a:avLst/>
-          </a:prstGeom>
-          <a:noFill/>
-        </p:spPr>
-        <p:txBody>
-          <a:bodyPr wrap="square">
-            <a:spAutoFit/>
-          </a:bodyPr>
-          <a:lstStyle/>
-          <a:p>
-            <a:pPr algn="l">
-              <a:defRPr sz="2000" b="1">
-                <a:solidFill>
-                  <a:srgbClr val="1B3A5C"/>
-                </a:solidFill>
-                <a:latin typeface="Calibri"/>
-              </a:defRPr>
-            </a:pPr>
-            <a:r>
-              <a:t>inversion/</a:t>
-            </a:r>
-          </a:p>
-        </p:txBody>
-      </p:sp>
-      <p:sp>
-        <p:nvSpPr>
-          <p:cNvPr id="7" name="TextBox 6"/>
-          <p:cNvSpPr txBox="1"/>
-          <p:nvPr/>
-        </p:nvSpPr>
-        <p:spPr>
-          <a:xfrm>
-            <a:off x="3657600" y="2240280"/>
-            <a:ext cx="7315200" cy="457200"/>
-          </a:xfrm>
-          <a:prstGeom prst="rect">
-            <a:avLst/>
-          </a:prstGeom>
-          <a:noFill/>
-        </p:spPr>
-        <p:txBody>
-          <a:bodyPr wrap="square">
-            <a:spAutoFit/>
-          </a:bodyPr>
-          <a:lstStyle/>
-          <a:p>
-            <a:pPr algn="l">
-              <a:defRPr sz="1600" b="0">
-                <a:solidFill>
-                  <a:srgbClr val="333333"/>
-                </a:solidFill>
-                <a:latin typeface="Calibri"/>
-              </a:defRPr>
-            </a:pPr>
-            <a:r>
-              <a:t>Adjoint, objective, regularisation, optimizer, geometry, multi-scale</a:t>
-            </a:r>
-          </a:p>
-        </p:txBody>
-      </p:sp>
-      <p:sp>
-        <p:nvSpPr>
-          <p:cNvPr id="8" name="TextBox 7"/>
-          <p:cNvSpPr txBox="1"/>
-          <p:nvPr/>
-        </p:nvSpPr>
-        <p:spPr>
-          <a:xfrm>
-            <a:off x="914400" y="3017520"/>
-            <a:ext cx="2743200" cy="457200"/>
-          </a:xfrm>
-          <a:prstGeom prst="rect">
-            <a:avLst/>
-          </a:prstGeom>
-          <a:noFill/>
-        </p:spPr>
-        <p:txBody>
-          <a:bodyPr wrap="square">
-            <a:spAutoFit/>
-          </a:bodyPr>
-          <a:lstStyle/>
-          <a:p>
-            <a:pPr algn="l">
-              <a:defRPr sz="2000" b="1">
-                <a:solidFill>
-                  <a:srgbClr val="1B3A5C"/>
-                </a:solidFill>
-                <a:latin typeface="Calibri"/>
-              </a:defRPr>
-            </a:pPr>
-            <a:r>
-              <a:t>gpu/</a:t>
-            </a:r>
-          </a:p>
-        </p:txBody>
-      </p:sp>
-      <p:sp>
-        <p:nvSpPr>
-          <p:cNvPr id="9" name="TextBox 8"/>
-          <p:cNvSpPr txBox="1"/>
-          <p:nvPr/>
-        </p:nvSpPr>
-        <p:spPr>
-          <a:xfrm>
-            <a:off x="3657600" y="3017520"/>
-            <a:ext cx="7315200" cy="457200"/>
-          </a:xfrm>
-          <a:prstGeom prst="rect">
-            <a:avLst/>
-          </a:prstGeom>
-          <a:noFill/>
-        </p:spPr>
-        <p:txBody>
-          <a:bodyPr wrap="square">
-            <a:spAutoFit/>
-          </a:bodyPr>
-          <a:lstStyle/>
-          <a:p>
-            <a:pPr algn="l">
-              <a:defRPr sz="1600" b="0">
-                <a:solidFill>
-                  <a:srgbClr val="333333"/>
-                </a:solidFill>
-                <a:latin typeface="Calibri"/>
-              </a:defRPr>
-            </a:pPr>
-            <a:r>
-              <a:t>CuPy FDTD, GPU CPML, benchmarking</a:t>
-            </a:r>
-          </a:p>
-        </p:txBody>
-      </p:sp>
-      <p:sp>
-        <p:nvSpPr>
-          <p:cNvPr id="10" name="TextBox 9"/>
-          <p:cNvSpPr txBox="1"/>
-          <p:nvPr/>
-        </p:nvSpPr>
-        <p:spPr>
-          <a:xfrm>
-            <a:off x="914400" y="3794760"/>
-            <a:ext cx="2743200" cy="457200"/>
-          </a:xfrm>
-          <a:prstGeom prst="rect">
-            <a:avLst/>
-          </a:prstGeom>
-          <a:noFill/>
-        </p:spPr>
-        <p:txBody>
-          <a:bodyPr wrap="square">
-            <a:spAutoFit/>
-          </a:bodyPr>
-          <a:lstStyle/>
-          <a:p>
-            <a:pPr algn="l">
-              <a:defRPr sz="2000" b="1">
-                <a:solidFill>
-                  <a:srgbClr val="1B3A5C"/>
-                </a:solidFill>
-                <a:latin typeface="Calibri"/>
-              </a:defRPr>
-            </a:pPr>
-            <a:r>
-              <a:t>visualization/</a:t>
-            </a:r>
-          </a:p>
-        </p:txBody>
-      </p:sp>
-      <p:sp>
-        <p:nvSpPr>
-          <p:cNvPr id="11" name="TextBox 10"/>
-          <p:cNvSpPr txBox="1"/>
-          <p:nvPr/>
-        </p:nvSpPr>
-        <p:spPr>
-          <a:xfrm>
-            <a:off x="3657600" y="3794760"/>
-            <a:ext cx="7315200" cy="457200"/>
-          </a:xfrm>
-          <a:prstGeom prst="rect">
-            <a:avLst/>
-          </a:prstGeom>
-          <a:noFill/>
-        </p:spPr>
-        <p:txBody>
-          <a:bodyPr wrap="square">
-            <a:spAutoFit/>
-          </a:bodyPr>
-          <a:lstStyle/>
-          <a:p>
-            <a:pPr algn="l">
-              <a:defRPr sz="1600" b="0">
-                <a:solidFill>
-                  <a:srgbClr val="333333"/>
-                </a:solidFill>
-                <a:latin typeface="Calibri"/>
-              </a:defRPr>
-            </a:pPr>
-            <a:r>
-              <a:t>All plotting modules</a:t>
-            </a:r>
-          </a:p>
-        </p:txBody>
-      </p:sp>
-      <p:sp>
-        <p:nvSpPr>
-          <p:cNvPr id="12" name="TextBox 11"/>
-          <p:cNvSpPr txBox="1"/>
-          <p:nvPr/>
-        </p:nvSpPr>
-        <p:spPr>
-          <a:xfrm>
-            <a:off x="914400" y="4572000"/>
-            <a:ext cx="2743200" cy="457200"/>
-          </a:xfrm>
-          <a:prstGeom prst="rect">
-            <a:avLst/>
-          </a:prstGeom>
-          <a:noFill/>
-        </p:spPr>
-        <p:txBody>
-          <a:bodyPr wrap="square">
-            <a:spAutoFit/>
-          </a:bodyPr>
-          <a:lstStyle/>
-          <a:p>
-            <a:pPr algn="l">
-              <a:defRPr sz="2000" b="1">
-                <a:solidFill>
-                  <a:srgbClr val="1B3A5C"/>
-                </a:solidFill>
-                <a:latin typeface="Calibri"/>
-              </a:defRPr>
-            </a:pPr>
-            <a:r>
-              <a:t>tests/</a:t>
-            </a:r>
-          </a:p>
-        </p:txBody>
-      </p:sp>
-      <p:sp>
-        <p:nvSpPr>
-          <p:cNvPr id="13" name="TextBox 12"/>
-          <p:cNvSpPr txBox="1"/>
-          <p:nvPr/>
-        </p:nvSpPr>
-        <p:spPr>
-          <a:xfrm>
-            <a:off x="3657600" y="4572000"/>
-            <a:ext cx="7315200" cy="457200"/>
-          </a:xfrm>
-          <a:prstGeom prst="rect">
-            <a:avLst/>
-          </a:prstGeom>
-          <a:noFill/>
-        </p:spPr>
-        <p:txBody>
-          <a:bodyPr wrap="square">
-            <a:spAutoFit/>
-          </a:bodyPr>
-          <a:lstStyle/>
-          <a:p>
-            <a:pPr algn="l">
-              <a:defRPr sz="1600" b="0">
-                <a:solidFill>
-                  <a:srgbClr val="333333"/>
-                </a:solidFill>
-                <a:latin typeface="Calibri"/>
-              </a:defRPr>
-            </a:pPr>
-            <a:r>
-              <a:t>6 verification tests (all pass)</a:t>
-            </a:r>
-          </a:p>
-        </p:txBody>
-      </p:sp>
-      <p:sp>
-        <p:nvSpPr>
-          <p:cNvPr id="14" name="TextBox 13"/>
-          <p:cNvSpPr txBox="1"/>
-          <p:nvPr/>
-        </p:nvSpPr>
-        <p:spPr>
-          <a:xfrm>
-            <a:off x="8229600" y="5029200"/>
-            <a:ext cx="2743200" cy="1097280"/>
-          </a:xfrm>
-          <a:prstGeom prst="rect">
-            <a:avLst/>
-          </a:prstGeom>
-          <a:noFill/>
-        </p:spPr>
-        <p:txBody>
-          <a:bodyPr wrap="square">
-            <a:spAutoFit/>
-          </a:bodyPr>
-          <a:lstStyle/>
-          <a:p>
             <a:pPr algn="ctr">
-              <a:defRPr sz="3600" b="1">
-                <a:solidFill>
-                  <a:srgbClr val="2E7D32"/>
-                </a:solidFill>
-                <a:latin typeface="Calibri"/>
-              </a:defRPr>
-            </a:pPr>
-            <a:r>
-              <a:t>~2,500</a:t>
-            </a:r>
-          </a:p>
-          <a:p>
-            <a:pPr algn="ctr">
-              <a:defRPr sz="1400">
-                <a:solidFill>
-                  <a:srgbClr val="333333"/>
-                </a:solidFill>
-                <a:latin typeface="Calibri"/>
-              </a:defRPr>
-            </a:pPr>
-            <a:r>
-              <a:t>lines of Python</a:t>
+              <a:defRPr sz="1500" b="0">
+                <a:solidFill>
+                  <a:srgbClr val="333333"/>
+                </a:solidFill>
+                <a:latin typeface="Calibri"/>
+              </a:defRPr>
+            </a:pPr>
+            <a:r>
+              <a:t>Progressive refinement: 0.5 GHz (coarse) → 1.0 GHz (medium) → 1.5 GHz (fine)</a:t>
             </a:r>
           </a:p>
         </p:txBody>
@@ -9157,7 +9513,7 @@
         <p:spPr>
           <a:xfrm>
             <a:off x="0" y="0"/>
-            <a:ext cx="12191695" cy="6858000"/>
+            <a:ext cx="12191695" cy="1005840"/>
           </a:xfrm>
           <a:prstGeom prst="rect">
             <a:avLst/>
@@ -9165,6 +9521,9 @@
           <a:solidFill>
             <a:srgbClr val="1B3A5C"/>
           </a:solidFill>
+          <a:ln>
+            <a:noFill/>
+          </a:ln>
         </p:spPr>
         <p:style>
           <a:lnRef idx="1">
@@ -9196,8 +9555,8 @@
         </p:nvSpPr>
         <p:spPr>
           <a:xfrm>
-            <a:off x="457200" y="457200"/>
-            <a:ext cx="10972800" cy="731520"/>
+            <a:off x="548640" y="137160"/>
+            <a:ext cx="10972800" cy="640080"/>
           </a:xfrm>
           <a:prstGeom prst="rect">
             <a:avLst/>
@@ -9210,8 +9569,8 @@
           </a:bodyPr>
           <a:lstStyle/>
           <a:p>
-            <a:pPr algn="ctr">
-              <a:defRPr sz="3000" b="1">
+            <a:pPr>
+              <a:defRPr sz="2800" b="1">
                 <a:solidFill>
                   <a:srgbClr val="FFFFFF"/>
                 </a:solidFill>
@@ -9219,7 +9578,7 @@
               </a:defRPr>
             </a:pPr>
             <a:r>
-              <a:t>Summary &amp; Key Contributions</a:t>
+              <a:t>Software Architecture</a:t>
             </a:r>
           </a:p>
         </p:txBody>
@@ -9232,8 +9591,8 @@
         </p:nvSpPr>
         <p:spPr>
           <a:xfrm>
-            <a:off x="1371600" y="1463040"/>
-            <a:ext cx="9144000" cy="457200"/>
+            <a:off x="914400" y="1463040"/>
+            <a:ext cx="2743200" cy="457200"/>
           </a:xfrm>
           <a:prstGeom prst="rect">
             <a:avLst/>
@@ -9247,15 +9606,15 @@
           <a:lstStyle/>
           <a:p>
             <a:pPr algn="l">
-              <a:defRPr sz="1800" b="0">
-                <a:solidFill>
-                  <a:srgbClr val="FFFFFF"/>
-                </a:solidFill>
-                <a:latin typeface="Calibri"/>
-              </a:defRPr>
-            </a:pPr>
-            <a:r>
-              <a:t>Complete 2D TMz FDTD solver with CPML — 6/6 tests pass</a:t>
+              <a:defRPr sz="2000" b="1">
+                <a:solidFill>
+                  <a:srgbClr val="1B3A5C"/>
+                </a:solidFill>
+                <a:latin typeface="Calibri"/>
+              </a:defRPr>
+            </a:pPr>
+            <a:r>
+              <a:t>core/</a:t>
             </a:r>
           </a:p>
         </p:txBody>
@@ -9268,8 +9627,8 @@
         </p:nvSpPr>
         <p:spPr>
           <a:xfrm>
-            <a:off x="1371600" y="2011680"/>
-            <a:ext cx="9144000" cy="457200"/>
+            <a:off x="3657600" y="1463040"/>
+            <a:ext cx="7315200" cy="457200"/>
           </a:xfrm>
           <a:prstGeom prst="rect">
             <a:avLst/>
@@ -9283,15 +9642,15 @@
           <a:lstStyle/>
           <a:p>
             <a:pPr algn="l">
-              <a:defRPr sz="1800" b="0">
-                <a:solidFill>
-                  <a:srgbClr val="FFFFFF"/>
-                </a:solidFill>
-                <a:latin typeface="Calibri"/>
-              </a:defRPr>
-            </a:pPr>
-            <a:r>
-              <a:t>Adjoint gradient validated to 0.4% vs finite differences</a:t>
+              <a:defRPr sz="1600" b="0">
+                <a:solidFill>
+                  <a:srgbClr val="333333"/>
+                </a:solidFill>
+                <a:latin typeface="Calibri"/>
+              </a:defRPr>
+            </a:pPr>
+            <a:r>
+              <a:t>FDTD engine, CPML, materials, geometry, source, scan</a:t>
             </a:r>
           </a:p>
         </p:txBody>
@@ -9304,8 +9663,8 @@
         </p:nvSpPr>
         <p:spPr>
           <a:xfrm>
-            <a:off x="1371600" y="2560320"/>
-            <a:ext cx="9144000" cy="457200"/>
+            <a:off x="914400" y="2240280"/>
+            <a:ext cx="2743200" cy="457200"/>
           </a:xfrm>
           <a:prstGeom prst="rect">
             <a:avLst/>
@@ -9319,15 +9678,15 @@
           <a:lstStyle/>
           <a:p>
             <a:pPr algn="l">
-              <a:defRPr sz="1800" b="0">
-                <a:solidFill>
-                  <a:srgbClr val="FFFFFF"/>
-                </a:solidFill>
-                <a:latin typeface="Calibri"/>
-              </a:defRPr>
-            </a:pPr>
-            <a:r>
-              <a:t>Geometry inversion: 9 params, &lt; 3 mm position error, &lt; 1 mm depth</a:t>
+              <a:defRPr sz="2000" b="1">
+                <a:solidFill>
+                  <a:srgbClr val="1B3A5C"/>
+                </a:solidFill>
+                <a:latin typeface="Calibri"/>
+              </a:defRPr>
+            </a:pPr>
+            <a:r>
+              <a:t>inversion/</a:t>
             </a:r>
           </a:p>
         </p:txBody>
@@ -9340,8 +9699,8 @@
         </p:nvSpPr>
         <p:spPr>
           <a:xfrm>
-            <a:off x="1371600" y="3108960"/>
-            <a:ext cx="9144000" cy="457200"/>
+            <a:off x="3657600" y="2240280"/>
+            <a:ext cx="7315200" cy="457200"/>
           </a:xfrm>
           <a:prstGeom prst="rect">
             <a:avLst/>
@@ -9355,15 +9714,15 @@
           <a:lstStyle/>
           <a:p>
             <a:pPr algn="l">
-              <a:defRPr sz="1800" b="0">
-                <a:solidFill>
-                  <a:srgbClr val="FFFFFF"/>
-                </a:solidFill>
-                <a:latin typeface="Calibri"/>
-              </a:defRPr>
-            </a:pPr>
-            <a:r>
-              <a:t>GPU acceleration: 3-7x speedup (CuPy), bit-identical CPML</a:t>
+              <a:defRPr sz="1600" b="0">
+                <a:solidFill>
+                  <a:srgbClr val="333333"/>
+                </a:solidFill>
+                <a:latin typeface="Calibri"/>
+              </a:defRPr>
+            </a:pPr>
+            <a:r>
+              <a:t>Adjoint, objective, regularisation, optimizer, geometry, multi-scale</a:t>
             </a:r>
           </a:p>
         </p:txBody>
@@ -9376,8 +9735,8 @@
         </p:nvSpPr>
         <p:spPr>
           <a:xfrm>
-            <a:off x="1371600" y="3657600"/>
-            <a:ext cx="9144000" cy="457200"/>
+            <a:off x="914400" y="3017520"/>
+            <a:ext cx="2743200" cy="457200"/>
           </a:xfrm>
           <a:prstGeom prst="rect">
             <a:avLst/>
@@ -9391,15 +9750,15 @@
           <a:lstStyle/>
           <a:p>
             <a:pPr algn="l">
-              <a:defRPr sz="1800" b="0">
-                <a:solidFill>
-                  <a:srgbClr val="FFFFFF"/>
-                </a:solidFill>
-                <a:latin typeface="Calibri"/>
-              </a:defRPr>
-            </a:pPr>
-            <a:r>
-              <a:t>Extensions: Debye dispersion (~20%), dipole antenna (~40%),</a:t>
+              <a:defRPr sz="2000" b="1">
+                <a:solidFill>
+                  <a:srgbClr val="1B3A5C"/>
+                </a:solidFill>
+                <a:latin typeface="Calibri"/>
+              </a:defRPr>
+            </a:pPr>
+            <a:r>
+              <a:t>gpu/</a:t>
             </a:r>
           </a:p>
         </p:txBody>
@@ -9412,8 +9771,8 @@
         </p:nvSpPr>
         <p:spPr>
           <a:xfrm>
-            <a:off x="1371600" y="4206240"/>
-            <a:ext cx="9144000" cy="457200"/>
+            <a:off x="3657600" y="3017520"/>
+            <a:ext cx="7315200" cy="457200"/>
           </a:xfrm>
           <a:prstGeom prst="rect">
             <a:avLst/>
@@ -9427,15 +9786,15 @@
           <a:lstStyle/>
           <a:p>
             <a:pPr algn="l">
-              <a:defRPr sz="1800" b="0">
-                <a:solidFill>
-                  <a:srgbClr val="FFFFFF"/>
-                </a:solidFill>
-                <a:latin typeface="Calibri"/>
-              </a:defRPr>
-            </a:pPr>
-            <a:r>
-              <a:t>    multi-scale frequency continuation, dual-parameter adjoint</a:t>
+              <a:defRPr sz="1600" b="0">
+                <a:solidFill>
+                  <a:srgbClr val="333333"/>
+                </a:solidFill>
+                <a:latin typeface="Calibri"/>
+              </a:defRPr>
+            </a:pPr>
+            <a:r>
+              <a:t>CuPy FDTD, GPU CPML, benchmarking</a:t>
             </a:r>
           </a:p>
         </p:txBody>
@@ -9448,8 +9807,8 @@
         </p:nvSpPr>
         <p:spPr>
           <a:xfrm>
-            <a:off x="1371600" y="4754879"/>
-            <a:ext cx="9144000" cy="457200"/>
+            <a:off x="914400" y="3794760"/>
+            <a:ext cx="2743200" cy="457200"/>
           </a:xfrm>
           <a:prstGeom prst="rect">
             <a:avLst/>
@@ -9463,13 +9822,16 @@
           <a:lstStyle/>
           <a:p>
             <a:pPr algn="l">
-              <a:defRPr sz="1800" b="0">
-                <a:solidFill>
-                  <a:srgbClr val="FFFFFF"/>
-                </a:solidFill>
-                <a:latin typeface="Calibri"/>
-              </a:defRPr>
-            </a:pPr>
+              <a:defRPr sz="2000" b="1">
+                <a:solidFill>
+                  <a:srgbClr val="1B3A5C"/>
+                </a:solidFill>
+                <a:latin typeface="Calibri"/>
+              </a:defRPr>
+            </a:pPr>
+            <a:r>
+              <a:t>visualization/</a:t>
+            </a:r>
           </a:p>
         </p:txBody>
       </p:sp>
@@ -9481,8 +9843,8 @@
         </p:nvSpPr>
         <p:spPr>
           <a:xfrm>
-            <a:off x="1371600" y="5303520"/>
-            <a:ext cx="9144000" cy="457200"/>
+            <a:off x="3657600" y="3794760"/>
+            <a:ext cx="7315200" cy="457200"/>
           </a:xfrm>
           <a:prstGeom prst="rect">
             <a:avLst/>
@@ -9496,6 +9858,257 @@
           <a:lstStyle/>
           <a:p>
             <a:pPr algn="l">
+              <a:defRPr sz="1600" b="0">
+                <a:solidFill>
+                  <a:srgbClr val="333333"/>
+                </a:solidFill>
+                <a:latin typeface="Calibri"/>
+              </a:defRPr>
+            </a:pPr>
+            <a:r>
+              <a:t>All plotting modules</a:t>
+            </a:r>
+          </a:p>
+        </p:txBody>
+      </p:sp>
+      <p:sp>
+        <p:nvSpPr>
+          <p:cNvPr id="12" name="TextBox 11"/>
+          <p:cNvSpPr txBox="1"/>
+          <p:nvPr/>
+        </p:nvSpPr>
+        <p:spPr>
+          <a:xfrm>
+            <a:off x="914400" y="4572000"/>
+            <a:ext cx="2743200" cy="457200"/>
+          </a:xfrm>
+          <a:prstGeom prst="rect">
+            <a:avLst/>
+          </a:prstGeom>
+          <a:noFill/>
+        </p:spPr>
+        <p:txBody>
+          <a:bodyPr wrap="square">
+            <a:spAutoFit/>
+          </a:bodyPr>
+          <a:lstStyle/>
+          <a:p>
+            <a:pPr algn="l">
+              <a:defRPr sz="2000" b="1">
+                <a:solidFill>
+                  <a:srgbClr val="1B3A5C"/>
+                </a:solidFill>
+                <a:latin typeface="Calibri"/>
+              </a:defRPr>
+            </a:pPr>
+            <a:r>
+              <a:t>tests/</a:t>
+            </a:r>
+          </a:p>
+        </p:txBody>
+      </p:sp>
+      <p:sp>
+        <p:nvSpPr>
+          <p:cNvPr id="13" name="TextBox 12"/>
+          <p:cNvSpPr txBox="1"/>
+          <p:nvPr/>
+        </p:nvSpPr>
+        <p:spPr>
+          <a:xfrm>
+            <a:off x="3657600" y="4572000"/>
+            <a:ext cx="7315200" cy="457200"/>
+          </a:xfrm>
+          <a:prstGeom prst="rect">
+            <a:avLst/>
+          </a:prstGeom>
+          <a:noFill/>
+        </p:spPr>
+        <p:txBody>
+          <a:bodyPr wrap="square">
+            <a:spAutoFit/>
+          </a:bodyPr>
+          <a:lstStyle/>
+          <a:p>
+            <a:pPr algn="l">
+              <a:defRPr sz="1600" b="0">
+                <a:solidFill>
+                  <a:srgbClr val="333333"/>
+                </a:solidFill>
+                <a:latin typeface="Calibri"/>
+              </a:defRPr>
+            </a:pPr>
+            <a:r>
+              <a:t>6 verification tests (all pass)</a:t>
+            </a:r>
+          </a:p>
+        </p:txBody>
+      </p:sp>
+      <p:sp>
+        <p:nvSpPr>
+          <p:cNvPr id="14" name="TextBox 13"/>
+          <p:cNvSpPr txBox="1"/>
+          <p:nvPr/>
+        </p:nvSpPr>
+        <p:spPr>
+          <a:xfrm>
+            <a:off x="8229600" y="5029200"/>
+            <a:ext cx="2743200" cy="1097280"/>
+          </a:xfrm>
+          <a:prstGeom prst="rect">
+            <a:avLst/>
+          </a:prstGeom>
+          <a:noFill/>
+        </p:spPr>
+        <p:txBody>
+          <a:bodyPr wrap="square">
+            <a:spAutoFit/>
+          </a:bodyPr>
+          <a:lstStyle/>
+          <a:p>
+            <a:pPr algn="ctr">
+              <a:defRPr sz="3600" b="1">
+                <a:solidFill>
+                  <a:srgbClr val="2E7D32"/>
+                </a:solidFill>
+                <a:latin typeface="Calibri"/>
+              </a:defRPr>
+            </a:pPr>
+            <a:r>
+              <a:t>~2,500</a:t>
+            </a:r>
+          </a:p>
+          <a:p>
+            <a:pPr algn="ctr">
+              <a:defRPr sz="1400">
+                <a:solidFill>
+                  <a:srgbClr val="333333"/>
+                </a:solidFill>
+                <a:latin typeface="Calibri"/>
+              </a:defRPr>
+            </a:pPr>
+            <a:r>
+              <a:t>lines of Python</a:t>
+            </a:r>
+          </a:p>
+        </p:txBody>
+      </p:sp>
+    </p:spTree>
+  </p:cSld>
+  <p:clrMapOvr>
+    <a:masterClrMapping/>
+  </p:clrMapOvr>
+</p:sld>
+</file>
+
+<file path=ppt/slides/slide24.xml><?xml version="1.0" encoding="utf-8"?>
+<p:sld xmlns:a="http://schemas.openxmlformats.org/drawingml/2006/main" xmlns:p="http://schemas.openxmlformats.org/presentationml/2006/main" xmlns:r="http://schemas.openxmlformats.org/officeDocument/2006/relationships">
+  <p:cSld>
+    <p:spTree>
+      <p:nvGrpSpPr>
+        <p:cNvPr id="1" name=""/>
+        <p:cNvGrpSpPr/>
+        <p:nvPr/>
+      </p:nvGrpSpPr>
+      <p:grpSpPr/>
+      <p:sp>
+        <p:nvSpPr>
+          <p:cNvPr id="2" name="Rectangle 1"/>
+          <p:cNvSpPr/>
+          <p:nvPr/>
+        </p:nvSpPr>
+        <p:spPr>
+          <a:xfrm>
+            <a:off x="0" y="0"/>
+            <a:ext cx="12191695" cy="6858000"/>
+          </a:xfrm>
+          <a:prstGeom prst="rect">
+            <a:avLst/>
+          </a:prstGeom>
+          <a:solidFill>
+            <a:srgbClr val="1B3A5C"/>
+          </a:solidFill>
+        </p:spPr>
+        <p:style>
+          <a:lnRef idx="1">
+            <a:schemeClr val="accent1"/>
+          </a:lnRef>
+          <a:fillRef idx="3">
+            <a:schemeClr val="accent1"/>
+          </a:fillRef>
+          <a:effectRef idx="2">
+            <a:schemeClr val="accent1"/>
+          </a:effectRef>
+          <a:fontRef idx="minor">
+            <a:schemeClr val="lt1"/>
+          </a:fontRef>
+        </p:style>
+        <p:txBody>
+          <a:bodyPr rtlCol="0" anchor="ctr"/>
+          <a:lstStyle/>
+          <a:p>
+            <a:pPr algn="ctr"/>
+          </a:p>
+        </p:txBody>
+      </p:sp>
+      <p:sp>
+        <p:nvSpPr>
+          <p:cNvPr id="3" name="TextBox 2"/>
+          <p:cNvSpPr txBox="1"/>
+          <p:nvPr/>
+        </p:nvSpPr>
+        <p:spPr>
+          <a:xfrm>
+            <a:off x="457200" y="457200"/>
+            <a:ext cx="10972800" cy="731520"/>
+          </a:xfrm>
+          <a:prstGeom prst="rect">
+            <a:avLst/>
+          </a:prstGeom>
+          <a:noFill/>
+        </p:spPr>
+        <p:txBody>
+          <a:bodyPr wrap="square">
+            <a:spAutoFit/>
+          </a:bodyPr>
+          <a:lstStyle/>
+          <a:p>
+            <a:pPr algn="ctr">
+              <a:defRPr sz="3000" b="1">
+                <a:solidFill>
+                  <a:srgbClr val="FFFFFF"/>
+                </a:solidFill>
+                <a:latin typeface="Calibri"/>
+              </a:defRPr>
+            </a:pPr>
+            <a:r>
+              <a:t>Summary &amp; Key Contributions</a:t>
+            </a:r>
+          </a:p>
+        </p:txBody>
+      </p:sp>
+      <p:sp>
+        <p:nvSpPr>
+          <p:cNvPr id="4" name="TextBox 3"/>
+          <p:cNvSpPr txBox="1"/>
+          <p:nvPr/>
+        </p:nvSpPr>
+        <p:spPr>
+          <a:xfrm>
+            <a:off x="1371600" y="1463040"/>
+            <a:ext cx="9144000" cy="457200"/>
+          </a:xfrm>
+          <a:prstGeom prst="rect">
+            <a:avLst/>
+          </a:prstGeom>
+          <a:noFill/>
+        </p:spPr>
+        <p:txBody>
+          <a:bodyPr wrap="square">
+            <a:spAutoFit/>
+          </a:bodyPr>
+          <a:lstStyle/>
+          <a:p>
+            <a:pPr algn="l">
               <a:defRPr sz="1800" b="0">
                 <a:solidFill>
                   <a:srgbClr val="FFFFFF"/>
@@ -9504,6 +10117,291 @@
               </a:defRPr>
             </a:pPr>
             <a:r>
+              <a:t>1.  Complete 2D TMz FDTD solver with CPML — 6/6 tests pass</a:t>
+            </a:r>
+          </a:p>
+        </p:txBody>
+      </p:sp>
+      <p:sp>
+        <p:nvSpPr>
+          <p:cNvPr id="5" name="TextBox 4"/>
+          <p:cNvSpPr txBox="1"/>
+          <p:nvPr/>
+        </p:nvSpPr>
+        <p:spPr>
+          <a:xfrm>
+            <a:off x="1371600" y="2011680"/>
+            <a:ext cx="9144000" cy="457200"/>
+          </a:xfrm>
+          <a:prstGeom prst="rect">
+            <a:avLst/>
+          </a:prstGeom>
+          <a:noFill/>
+        </p:spPr>
+        <p:txBody>
+          <a:bodyPr wrap="square">
+            <a:spAutoFit/>
+          </a:bodyPr>
+          <a:lstStyle/>
+          <a:p>
+            <a:pPr algn="l">
+              <a:defRPr sz="1800" b="0">
+                <a:solidFill>
+                  <a:srgbClr val="FFFFFF"/>
+                </a:solidFill>
+                <a:latin typeface="Calibri"/>
+              </a:defRPr>
+            </a:pPr>
+            <a:r>
+              <a:t>2.  Adjoint gradient validated to 0.4% vs finite differences</a:t>
+            </a:r>
+          </a:p>
+        </p:txBody>
+      </p:sp>
+      <p:sp>
+        <p:nvSpPr>
+          <p:cNvPr id="6" name="TextBox 5"/>
+          <p:cNvSpPr txBox="1"/>
+          <p:nvPr/>
+        </p:nvSpPr>
+        <p:spPr>
+          <a:xfrm>
+            <a:off x="1371600" y="2560320"/>
+            <a:ext cx="9144000" cy="457200"/>
+          </a:xfrm>
+          <a:prstGeom prst="rect">
+            <a:avLst/>
+          </a:prstGeom>
+          <a:noFill/>
+        </p:spPr>
+        <p:txBody>
+          <a:bodyPr wrap="square">
+            <a:spAutoFit/>
+          </a:bodyPr>
+          <a:lstStyle/>
+          <a:p>
+            <a:pPr algn="l">
+              <a:defRPr sz="1800" b="0">
+                <a:solidFill>
+                  <a:srgbClr val="FFFFFF"/>
+                </a:solidFill>
+                <a:latin typeface="Calibri"/>
+              </a:defRPr>
+            </a:pPr>
+            <a:r>
+              <a:t>3.  Pixel-wise FWI: correct but impractical → evidence-based pivot</a:t>
+            </a:r>
+          </a:p>
+        </p:txBody>
+      </p:sp>
+      <p:sp>
+        <p:nvSpPr>
+          <p:cNvPr id="7" name="TextBox 6"/>
+          <p:cNvSpPr txBox="1"/>
+          <p:nvPr/>
+        </p:nvSpPr>
+        <p:spPr>
+          <a:xfrm>
+            <a:off x="1371600" y="3108960"/>
+            <a:ext cx="9144000" cy="457200"/>
+          </a:xfrm>
+          <a:prstGeom prst="rect">
+            <a:avLst/>
+          </a:prstGeom>
+          <a:noFill/>
+        </p:spPr>
+        <p:txBody>
+          <a:bodyPr wrap="square">
+            <a:spAutoFit/>
+          </a:bodyPr>
+          <a:lstStyle/>
+          <a:p>
+            <a:pPr algn="l">
+              <a:defRPr sz="1800" b="0">
+                <a:solidFill>
+                  <a:srgbClr val="FFFFFF"/>
+                </a:solidFill>
+                <a:latin typeface="Calibri"/>
+              </a:defRPr>
+            </a:pPr>
+            <a:r>
+              <a:t>4.  Geometry inversion: 9 params, &lt; 3 mm position, &lt; 1 mm depth</a:t>
+            </a:r>
+          </a:p>
+        </p:txBody>
+      </p:sp>
+      <p:sp>
+        <p:nvSpPr>
+          <p:cNvPr id="8" name="TextBox 7"/>
+          <p:cNvSpPr txBox="1"/>
+          <p:nvPr/>
+        </p:nvSpPr>
+        <p:spPr>
+          <a:xfrm>
+            <a:off x="1371600" y="3657600"/>
+            <a:ext cx="9144000" cy="457200"/>
+          </a:xfrm>
+          <a:prstGeom prst="rect">
+            <a:avLst/>
+          </a:prstGeom>
+          <a:noFill/>
+        </p:spPr>
+        <p:txBody>
+          <a:bodyPr wrap="square">
+            <a:spAutoFit/>
+          </a:bodyPr>
+          <a:lstStyle/>
+          <a:p>
+            <a:pPr algn="l">
+              <a:defRPr sz="1800" b="0">
+                <a:solidFill>
+                  <a:srgbClr val="FFFFFF"/>
+                </a:solidFill>
+                <a:latin typeface="Calibri"/>
+              </a:defRPr>
+            </a:pPr>
+            <a:r>
+              <a:t>5.  GPU acceleration: 3.2-7.0x measured speedup, bit-identical CPML</a:t>
+            </a:r>
+          </a:p>
+        </p:txBody>
+      </p:sp>
+      <p:sp>
+        <p:nvSpPr>
+          <p:cNvPr id="9" name="TextBox 8"/>
+          <p:cNvSpPr txBox="1"/>
+          <p:nvPr/>
+        </p:nvSpPr>
+        <p:spPr>
+          <a:xfrm>
+            <a:off x="1371600" y="4206240"/>
+            <a:ext cx="9144000" cy="457200"/>
+          </a:xfrm>
+          <a:prstGeom prst="rect">
+            <a:avLst/>
+          </a:prstGeom>
+          <a:noFill/>
+        </p:spPr>
+        <p:txBody>
+          <a:bodyPr wrap="square">
+            <a:spAutoFit/>
+          </a:bodyPr>
+          <a:lstStyle/>
+          <a:p>
+            <a:pPr algn="l">
+              <a:defRPr sz="1800" b="0">
+                <a:solidFill>
+                  <a:srgbClr val="FFFFFF"/>
+                </a:solidFill>
+                <a:latin typeface="Calibri"/>
+              </a:defRPr>
+            </a:pPr>
+            <a:r>
+              <a:t>6.  Extensions: Debye dispersion (~20% effect), dipole antenna</a:t>
+            </a:r>
+          </a:p>
+        </p:txBody>
+      </p:sp>
+      <p:sp>
+        <p:nvSpPr>
+          <p:cNvPr id="10" name="TextBox 9"/>
+          <p:cNvSpPr txBox="1"/>
+          <p:nvPr/>
+        </p:nvSpPr>
+        <p:spPr>
+          <a:xfrm>
+            <a:off x="1371600" y="4754879"/>
+            <a:ext cx="9144000" cy="457200"/>
+          </a:xfrm>
+          <a:prstGeom prst="rect">
+            <a:avLst/>
+          </a:prstGeom>
+          <a:noFill/>
+        </p:spPr>
+        <p:txBody>
+          <a:bodyPr wrap="square">
+            <a:spAutoFit/>
+          </a:bodyPr>
+          <a:lstStyle/>
+          <a:p>
+            <a:pPr algn="l">
+              <a:defRPr sz="1800" b="0">
+                <a:solidFill>
+                  <a:srgbClr val="FFFFFF"/>
+                </a:solidFill>
+                <a:latin typeface="Calibri"/>
+              </a:defRPr>
+            </a:pPr>
+            <a:r>
+              <a:t>     (~40% effect), multi-scale frequency continuation</a:t>
+            </a:r>
+          </a:p>
+        </p:txBody>
+      </p:sp>
+      <p:sp>
+        <p:nvSpPr>
+          <p:cNvPr id="11" name="TextBox 10"/>
+          <p:cNvSpPr txBox="1"/>
+          <p:nvPr/>
+        </p:nvSpPr>
+        <p:spPr>
+          <a:xfrm>
+            <a:off x="1371600" y="5303520"/>
+            <a:ext cx="9144000" cy="457200"/>
+          </a:xfrm>
+          <a:prstGeom prst="rect">
+            <a:avLst/>
+          </a:prstGeom>
+          <a:noFill/>
+        </p:spPr>
+        <p:txBody>
+          <a:bodyPr wrap="square">
+            <a:spAutoFit/>
+          </a:bodyPr>
+          <a:lstStyle/>
+          <a:p>
+            <a:pPr algn="l">
+              <a:defRPr sz="1800" b="0">
+                <a:solidFill>
+                  <a:srgbClr val="FFFFFF"/>
+                </a:solidFill>
+                <a:latin typeface="Calibri"/>
+              </a:defRPr>
+            </a:pPr>
+          </a:p>
+        </p:txBody>
+      </p:sp>
+      <p:sp>
+        <p:nvSpPr>
+          <p:cNvPr id="12" name="TextBox 11"/>
+          <p:cNvSpPr txBox="1"/>
+          <p:nvPr/>
+        </p:nvSpPr>
+        <p:spPr>
+          <a:xfrm>
+            <a:off x="1371600" y="5852160"/>
+            <a:ext cx="9144000" cy="457200"/>
+          </a:xfrm>
+          <a:prstGeom prst="rect">
+            <a:avLst/>
+          </a:prstGeom>
+          <a:noFill/>
+        </p:spPr>
+        <p:txBody>
+          <a:bodyPr wrap="square">
+            <a:spAutoFit/>
+          </a:bodyPr>
+          <a:lstStyle/>
+          <a:p>
+            <a:pPr algn="l">
+              <a:defRPr sz="1800" b="0">
+                <a:solidFill>
+                  <a:srgbClr val="FFFFFF"/>
+                </a:solidFill>
+                <a:latin typeface="Calibri"/>
+              </a:defRPr>
+            </a:pPr>
+            <a:r>
               <a:t>All from scratch — ~2,500 lines of documented Python</a:t>
             </a:r>
           </a:p>
@@ -9511,7 +10409,7 @@
       </p:sp>
       <p:sp>
         <p:nvSpPr>
-          <p:cNvPr id="12" name="TextBox 11"/>
+          <p:cNvPr id="13" name="TextBox 12"/>
           <p:cNvSpPr txBox="1"/>
           <p:nvPr/>
         </p:nvSpPr>

</xml_diff>

<commit_message>
Rewrite slide 9 for readability: plain language, structured layout
Replaced dense math notation with approachable framing:
- "We have / We want / How" structure on the left
- "The cost problem" with intuitive explanation on the right
- Key numbers (50K pixels, ~4 hours) as visual callouts
- Speaker notes frame it as a detective analogy

Co-Authored-By: Claude Opus 4.6 (1M context) <noreply@anthropic.com>
</commit_message>
<xml_diff>
--- a/outputs/GPR_FDTD_FWI_Presentation.pptx
+++ b/outputs/GPR_FDTD_FWI_Presentation.pptx
@@ -2135,7 +2135,7 @@
           <a:lstStyle/>
           <a:p>
             <a:r>
-              <a:t>This frames the core challenge. Direct FD gradient is O(N) simulations.</a:t>
+              <a:t>Frame this as a detective problem: we have the clues (B-scan) and want to find the culprit (rebar positions). The challenge is that checking every possible change is prohibitively expensive — 50K forward simulations just to know which direction to step.</a:t>
             </a:r>
           </a:p>
         </p:txBody>
@@ -12417,7 +12417,7 @@
               </a:defRPr>
             </a:pPr>
             <a:r>
-              <a:t>The Inversion Problem</a:t>
+              <a:t>The Inverse Problem: From Data to Model</a:t>
             </a:r>
           </a:p>
         </p:txBody>
@@ -12430,8 +12430,8 @@
         </p:nvSpPr>
         <p:spPr>
           <a:xfrm>
-            <a:off x="457200" y="1371600"/>
-            <a:ext cx="6400800" cy="2743200"/>
+            <a:off x="457200" y="1280160"/>
+            <a:ext cx="5486400" cy="457200"/>
           </a:xfrm>
           <a:prstGeom prst="rect">
             <a:avLst/>
@@ -12444,51 +12444,205 @@
           </a:bodyPr>
           <a:lstStyle/>
           <a:p>
+            <a:pPr algn="l">
+              <a:defRPr sz="2000" b="1">
+                <a:solidFill>
+                  <a:srgbClr val="1B3A5C"/>
+                </a:solidFill>
+                <a:latin typeface="Calibri"/>
+              </a:defRPr>
+            </a:pPr>
+            <a:r>
+              <a:t>We have:</a:t>
+            </a:r>
+          </a:p>
+        </p:txBody>
+      </p:sp>
+      <p:sp>
+        <p:nvSpPr>
+          <p:cNvPr id="5" name="TextBox 4"/>
+          <p:cNvSpPr txBox="1"/>
+          <p:nvPr/>
+        </p:nvSpPr>
+        <p:spPr>
+          <a:xfrm>
+            <a:off x="731520" y="1737360"/>
+            <a:ext cx="5029200" cy="1097280"/>
+          </a:xfrm>
+          <a:prstGeom prst="rect">
+            <a:avLst/>
+          </a:prstGeom>
+          <a:noFill/>
+        </p:spPr>
+        <p:txBody>
+          <a:bodyPr wrap="square">
+            <a:spAutoFit/>
+          </a:bodyPr>
+          <a:lstStyle/>
+          <a:p>
             <a:pPr>
               <a:spcAft>
                 <a:spcPts val="600"/>
               </a:spcAft>
-              <a:defRPr sz="1800">
-                <a:solidFill>
-                  <a:srgbClr val="333333"/>
-                </a:solidFill>
-                <a:latin typeface="Calibri"/>
-              </a:defRPr>
-            </a:pPr>
-            <a:r>
-              <a:t>Given: observed B-scan data d_obs</a:t>
-            </a:r>
-          </a:p>
+              <a:defRPr sz="1700">
+                <a:solidFill>
+                  <a:srgbClr val="333333"/>
+                </a:solidFill>
+                <a:latin typeface="Calibri"/>
+              </a:defRPr>
+            </a:pPr>
+            <a:r>
+              <a:t>A B-scan radargram (recorded radar signals)</a:t>
+            </a:r>
+          </a:p>
+        </p:txBody>
+      </p:sp>
+      <p:sp>
+        <p:nvSpPr>
+          <p:cNvPr id="6" name="TextBox 5"/>
+          <p:cNvSpPr txBox="1"/>
+          <p:nvPr/>
+        </p:nvSpPr>
+        <p:spPr>
+          <a:xfrm>
+            <a:off x="457200" y="2560320"/>
+            <a:ext cx="5486400" cy="457200"/>
+          </a:xfrm>
+          <a:prstGeom prst="rect">
+            <a:avLst/>
+          </a:prstGeom>
+          <a:noFill/>
+        </p:spPr>
+        <p:txBody>
+          <a:bodyPr wrap="square">
+            <a:spAutoFit/>
+          </a:bodyPr>
+          <a:lstStyle/>
+          <a:p>
+            <a:pPr algn="l">
+              <a:defRPr sz="2000" b="1">
+                <a:solidFill>
+                  <a:srgbClr val="1B3A5C"/>
+                </a:solidFill>
+                <a:latin typeface="Calibri"/>
+              </a:defRPr>
+            </a:pPr>
+            <a:r>
+              <a:t>We want:</a:t>
+            </a:r>
+          </a:p>
+        </p:txBody>
+      </p:sp>
+      <p:sp>
+        <p:nvSpPr>
+          <p:cNvPr id="7" name="TextBox 6"/>
+          <p:cNvSpPr txBox="1"/>
+          <p:nvPr/>
+        </p:nvSpPr>
+        <p:spPr>
+          <a:xfrm>
+            <a:off x="731520" y="3017520"/>
+            <a:ext cx="5029200" cy="1097280"/>
+          </a:xfrm>
+          <a:prstGeom prst="rect">
+            <a:avLst/>
+          </a:prstGeom>
+          <a:noFill/>
+        </p:spPr>
+        <p:txBody>
+          <a:bodyPr wrap="square">
+            <a:spAutoFit/>
+          </a:bodyPr>
+          <a:lstStyle/>
           <a:p>
             <a:pPr>
               <a:spcAft>
                 <a:spcPts val="600"/>
               </a:spcAft>
-              <a:defRPr sz="1800">
-                <a:solidFill>
-                  <a:srgbClr val="333333"/>
-                </a:solidFill>
-                <a:latin typeface="Calibri"/>
-              </a:defRPr>
-            </a:pPr>
-            <a:r>
-              <a:t>Find: permittivity model m that explains the data</a:t>
-            </a:r>
-          </a:p>
+              <a:defRPr sz="1700">
+                <a:solidFill>
+                  <a:srgbClr val="333333"/>
+                </a:solidFill>
+                <a:latin typeface="Calibri"/>
+              </a:defRPr>
+            </a:pPr>
+            <a:r>
+              <a:t>The underground model (where are the rebars?)</a:t>
+            </a:r>
+          </a:p>
+        </p:txBody>
+      </p:sp>
+      <p:sp>
+        <p:nvSpPr>
+          <p:cNvPr id="8" name="TextBox 7"/>
+          <p:cNvSpPr txBox="1"/>
+          <p:nvPr/>
+        </p:nvSpPr>
+        <p:spPr>
+          <a:xfrm>
+            <a:off x="457200" y="3840480"/>
+            <a:ext cx="5486400" cy="457200"/>
+          </a:xfrm>
+          <a:prstGeom prst="rect">
+            <a:avLst/>
+          </a:prstGeom>
+          <a:noFill/>
+        </p:spPr>
+        <p:txBody>
+          <a:bodyPr wrap="square">
+            <a:spAutoFit/>
+          </a:bodyPr>
+          <a:lstStyle/>
+          <a:p>
+            <a:pPr algn="l">
+              <a:defRPr sz="2000" b="1">
+                <a:solidFill>
+                  <a:srgbClr val="1B3A5C"/>
+                </a:solidFill>
+                <a:latin typeface="Calibri"/>
+              </a:defRPr>
+            </a:pPr>
+            <a:r>
+              <a:t>How:</a:t>
+            </a:r>
+          </a:p>
+        </p:txBody>
+      </p:sp>
+      <p:sp>
+        <p:nvSpPr>
+          <p:cNvPr id="9" name="TextBox 8"/>
+          <p:cNvSpPr txBox="1"/>
+          <p:nvPr/>
+        </p:nvSpPr>
+        <p:spPr>
+          <a:xfrm>
+            <a:off x="731520" y="4297680"/>
+            <a:ext cx="5029200" cy="1828800"/>
+          </a:xfrm>
+          <a:prstGeom prst="rect">
+            <a:avLst/>
+          </a:prstGeom>
+          <a:noFill/>
+        </p:spPr>
+        <p:txBody>
+          <a:bodyPr wrap="square">
+            <a:spAutoFit/>
+          </a:bodyPr>
+          <a:lstStyle/>
           <a:p>
             <a:pPr>
               <a:spcAft>
                 <a:spcPts val="600"/>
               </a:spcAft>
-              <a:defRPr sz="1800">
-                <a:solidFill>
-                  <a:srgbClr val="333333"/>
-                </a:solidFill>
-                <a:latin typeface="Calibri"/>
-              </a:defRPr>
-            </a:pPr>
-            <a:r>
-              <a:t>Misfit: J(m) = 0.5 * ||d_obs - d_syn(m)||^2</a:t>
+              <a:defRPr sz="1700">
+                <a:solidFill>
+                  <a:srgbClr val="333333"/>
+                </a:solidFill>
+                <a:latin typeface="Calibri"/>
+              </a:defRPr>
+            </a:pPr>
+            <a:r>
+              <a:t>Adjust the model until simulated signals match observed ones</a:t>
             </a:r>
           </a:p>
           <a:p>
@@ -12496,28 +12650,90 @@
               <a:spcAft>
                 <a:spcPts val="600"/>
               </a:spcAft>
-              <a:defRPr sz="1800">
-                <a:solidFill>
-                  <a:srgbClr val="333333"/>
-                </a:solidFill>
-                <a:latin typeface="Calibri"/>
-              </a:defRPr>
-            </a:pPr>
-          </a:p>
+              <a:defRPr sz="1700">
+                <a:solidFill>
+                  <a:srgbClr val="333333"/>
+                </a:solidFill>
+                <a:latin typeface="Calibri"/>
+              </a:defRPr>
+            </a:pPr>
+            <a:r>
+              <a:t>Measure mismatch with a "misfit" score — then minimise it</a:t>
+            </a:r>
+          </a:p>
+        </p:txBody>
+      </p:sp>
+      <p:sp>
+        <p:nvSpPr>
+          <p:cNvPr id="10" name="TextBox 9"/>
+          <p:cNvSpPr txBox="1"/>
+          <p:nvPr/>
+        </p:nvSpPr>
+        <p:spPr>
+          <a:xfrm>
+            <a:off x="6400800" y="1280160"/>
+            <a:ext cx="5029200" cy="457200"/>
+          </a:xfrm>
+          <a:prstGeom prst="rect">
+            <a:avLst/>
+          </a:prstGeom>
+          <a:noFill/>
+        </p:spPr>
+        <p:txBody>
+          <a:bodyPr wrap="square">
+            <a:spAutoFit/>
+          </a:bodyPr>
+          <a:lstStyle/>
+          <a:p>
+            <a:pPr algn="l">
+              <a:defRPr sz="2000" b="1">
+                <a:solidFill>
+                  <a:srgbClr val="C62828"/>
+                </a:solidFill>
+                <a:latin typeface="Calibri"/>
+              </a:defRPr>
+            </a:pPr>
+            <a:r>
+              <a:t>The cost problem:</a:t>
+            </a:r>
+          </a:p>
+        </p:txBody>
+      </p:sp>
+      <p:sp>
+        <p:nvSpPr>
+          <p:cNvPr id="11" name="TextBox 10"/>
+          <p:cNvSpPr txBox="1"/>
+          <p:nvPr/>
+        </p:nvSpPr>
+        <p:spPr>
+          <a:xfrm>
+            <a:off x="6675120" y="1828800"/>
+            <a:ext cx="4754880" cy="2286000"/>
+          </a:xfrm>
+          <a:prstGeom prst="rect">
+            <a:avLst/>
+          </a:prstGeom>
+          <a:noFill/>
+        </p:spPr>
+        <p:txBody>
+          <a:bodyPr wrap="square">
+            <a:spAutoFit/>
+          </a:bodyPr>
+          <a:lstStyle/>
           <a:p>
             <a:pPr>
               <a:spcAft>
                 <a:spcPts val="600"/>
               </a:spcAft>
-              <a:defRPr sz="1800">
-                <a:solidFill>
-                  <a:srgbClr val="333333"/>
-                </a:solidFill>
-                <a:latin typeface="Calibri"/>
-              </a:defRPr>
-            </a:pPr>
-            <a:r>
-              <a:t>Naive approach: perturb each of 50,000 grid cells</a:t>
+              <a:defRPr sz="1600">
+                <a:solidFill>
+                  <a:srgbClr val="333333"/>
+                </a:solidFill>
+                <a:latin typeface="Calibri"/>
+              </a:defRPr>
+            </a:pPr>
+            <a:r>
+              <a:t>To know which direction to adjust,</a:t>
             </a:r>
           </a:p>
           <a:p>
@@ -12525,28 +12741,89 @@
               <a:spcAft>
                 <a:spcPts val="600"/>
               </a:spcAft>
-              <a:defRPr sz="1800">
-                <a:solidFill>
-                  <a:srgbClr val="333333"/>
-                </a:solidFill>
-                <a:latin typeface="Calibri"/>
-              </a:defRPr>
-            </a:pPr>
-            <a:r>
-              <a:t>  → 50,000 forward simulations per gradient!</a:t>
-            </a:r>
-          </a:p>
-        </p:txBody>
-      </p:sp>
-      <p:sp>
-        <p:nvSpPr>
-          <p:cNvPr id="5" name="TextBox 4"/>
+              <a:defRPr sz="1600">
+                <a:solidFill>
+                  <a:srgbClr val="333333"/>
+                </a:solidFill>
+                <a:latin typeface="Calibri"/>
+              </a:defRPr>
+            </a:pPr>
+            <a:r>
+              <a:t>we need a "gradient" — how does each</a:t>
+            </a:r>
+          </a:p>
+          <a:p>
+            <a:pPr>
+              <a:spcAft>
+                <a:spcPts val="600"/>
+              </a:spcAft>
+              <a:defRPr sz="1600">
+                <a:solidFill>
+                  <a:srgbClr val="333333"/>
+                </a:solidFill>
+                <a:latin typeface="Calibri"/>
+              </a:defRPr>
+            </a:pPr>
+            <a:r>
+              <a:t>pixel affect the misfit?</a:t>
+            </a:r>
+          </a:p>
+          <a:p>
+            <a:pPr>
+              <a:spcAft>
+                <a:spcPts val="600"/>
+              </a:spcAft>
+              <a:defRPr sz="1600">
+                <a:solidFill>
+                  <a:srgbClr val="333333"/>
+                </a:solidFill>
+                <a:latin typeface="Calibri"/>
+              </a:defRPr>
+            </a:pPr>
+          </a:p>
+          <a:p>
+            <a:pPr>
+              <a:spcAft>
+                <a:spcPts val="600"/>
+              </a:spcAft>
+              <a:defRPr sz="1600">
+                <a:solidFill>
+                  <a:srgbClr val="333333"/>
+                </a:solidFill>
+                <a:latin typeface="Calibri"/>
+              </a:defRPr>
+            </a:pPr>
+            <a:r>
+              <a:t>Brute force: tweak one pixel, re-run</a:t>
+            </a:r>
+          </a:p>
+          <a:p>
+            <a:pPr>
+              <a:spcAft>
+                <a:spcPts val="600"/>
+              </a:spcAft>
+              <a:defRPr sz="1600">
+                <a:solidFill>
+                  <a:srgbClr val="333333"/>
+                </a:solidFill>
+                <a:latin typeface="Calibri"/>
+              </a:defRPr>
+            </a:pPr>
+            <a:r>
+              <a:t>the simulation, repeat for every pixel</a:t>
+            </a:r>
+          </a:p>
+        </p:txBody>
+      </p:sp>
+      <p:sp>
+        <p:nvSpPr>
+          <p:cNvPr id="12" name="TextBox 11"/>
           <p:cNvSpPr txBox="1"/>
           <p:nvPr/>
         </p:nvSpPr>
         <p:spPr>
           <a:xfrm>
-            <a:off x="8229600" y="2286000"/>
+            <a:off x="7315200" y="4114800"/>
             <a:ext cx="2743200" cy="1097280"/>
           </a:xfrm>
           <a:prstGeom prst="rect">
@@ -12582,20 +12859,20 @@
               </a:defRPr>
             </a:pPr>
             <a:r>
-              <a:t>parameters</a:t>
-            </a:r>
-          </a:p>
-        </p:txBody>
-      </p:sp>
-      <p:sp>
-        <p:nvSpPr>
-          <p:cNvPr id="6" name="TextBox 5"/>
+              <a:t>pixels to check</a:t>
+            </a:r>
+          </a:p>
+        </p:txBody>
+      </p:sp>
+      <p:sp>
+        <p:nvSpPr>
+          <p:cNvPr id="13" name="TextBox 12"/>
           <p:cNvSpPr txBox="1"/>
           <p:nvPr/>
         </p:nvSpPr>
         <p:spPr>
           <a:xfrm>
-            <a:off x="8229600" y="4114800"/>
+            <a:off x="7315200" y="5303520"/>
             <a:ext cx="2743200" cy="1097280"/>
           </a:xfrm>
           <a:prstGeom prst="rect">
@@ -12618,7 +12895,7 @@
               </a:defRPr>
             </a:pPr>
             <a:r>
-              <a:t>~4 hrs</a:t>
+              <a:t>~4 hours</a:t>
             </a:r>
           </a:p>
           <a:p>
@@ -12631,7 +12908,7 @@
               </a:defRPr>
             </a:pPr>
             <a:r>
-              <a:t>per naive gradient</a:t>
+              <a:t>per brute-force gradient</a:t>
             </a:r>
           </a:p>
         </p:txBody>

</xml_diff>